<commit_message>
docs: update FEA-vs-bench slides with re-measured ring-down resonance (38.5Hz -> 47-50Hz, superseded)
</commit_message>
<xml_diff>
--- a/docs/session_results_2026-08-18_pid_tuning.pptx
+++ b/docs/session_results_2026-08-18_pid_tuning.pptx
@@ -5321,7 +5321,7 @@
                 </a:solidFill>
                 <a:latin typeface="Calibri"/>
               </a:rPr>
-              <a:t>Bench resonance runs ~20% below FEA — rescaling the 0.75mm-arm prediction</a:t>
+              <a:t>Bench resonance re-measured: 38.5Hz → ~47-50Hz — now close to FEA, not 20% below it</a:t>
             </a:r>
           </a:p>
         </p:txBody>
@@ -5385,11 +5385,36 @@
           <a:p>
             <a:pPr>
               <a:spcAft>
-                <a:spcPts val="900"/>
+                <a:spcPts val="600"/>
               </a:spcAft>
             </a:pPr>
             <a:r>
-              <a:rPr sz="1250">
+              <a:rPr sz="1150" b="1">
+                <a:solidFill>
+                  <a:srgbClr val="333333"/>
+                </a:solidFill>
+                <a:latin typeface="Calibri"/>
+              </a:rPr>
+              <a:t>Superseded number, stated plainly: </a:t>
+            </a:r>
+            <a:r>
+              <a:rPr sz="1150">
+                <a:solidFill>
+                  <a:srgbClr val="333333"/>
+                </a:solidFill>
+                <a:latin typeface="Calibri"/>
+              </a:rPr>
+              <a:t>38.5Hz (previous bode/ring-down) is superseded — after fixing ring-down timing bugs and testing both axes, the same peak-spacing method now reads 47.0-47.3Hz (x-axis, 2 trials) and 50.1Hz (y-axis, 1 trial). A real physical shift per CLAUDE.md, not a methodology fix; cause not yet identified.</a:t>
+            </a:r>
+          </a:p>
+          <a:p>
+            <a:pPr>
+              <a:spcAft>
+                <a:spcPts val="600"/>
+              </a:spcAft>
+            </a:pPr>
+            <a:r>
+              <a:rPr sz="1150">
                 <a:solidFill>
                   <a:srgbClr val="333333"/>
                 </a:solidFill>
@@ -5398,23 +5423,23 @@
               <a:t>• </a:t>
             </a:r>
             <a:r>
-              <a:rPr sz="1250">
-                <a:solidFill>
-                  <a:srgbClr val="333333"/>
-                </a:solidFill>
-                <a:latin typeface="Calibri"/>
-              </a:rPr>
-              <a:t>The cross-validated bench resonance for the current 0.5mm flexure is 38.5Hz (bode peak + ring-down peak-spacing, previous slides) — the FEA modal analysis on the same 0.5mm part predicts mode 1 at 48.19Hz, mode 2 at 52.92Hz.</a:t>
+              <a:rPr sz="1150">
+                <a:solidFill>
+                  <a:srgbClr val="333333"/>
+                </a:solidFill>
+                <a:latin typeface="Calibri"/>
+              </a:rPr>
+              <a:t>0.5mm FEA has two close bending modes (48.19Hz, 52.92Hz) — pairing x-axis↔mode 1, y-axis↔mode 2 gives measured/FEA = 0.978 and 0.947: within ~2-5% of FEA, not the ~20% gap previously reported.</a:t>
             </a:r>
           </a:p>
           <a:p>
             <a:pPr>
               <a:spcAft>
-                <a:spcPts val="900"/>
+                <a:spcPts val="600"/>
               </a:spcAft>
             </a:pPr>
             <a:r>
-              <a:rPr sz="1250">
+              <a:rPr sz="1150">
                 <a:solidFill>
                   <a:srgbClr val="333333"/>
                 </a:solidFill>
@@ -5423,23 +5448,23 @@
               <a:t>• </a:t>
             </a:r>
             <a:r>
-              <a:rPr sz="1250">
-                <a:solidFill>
-                  <a:srgbClr val="333333"/>
-                </a:solidFill>
-                <a:latin typeface="Calibri"/>
-              </a:rPr>
-              <a:t>That's the model running ~20% high (measured/FEA = 0.80) — expected for a bolted flexure: FEA assumes a perfectly rigid clamp, the real joint has bolt-preload/contact compliance plus unmodeled fiber and connector mass, both of which lower the true frequency.</a:t>
+              <a:rPr sz="1150">
+                <a:solidFill>
+                  <a:srgbClr val="333333"/>
+                </a:solidFill>
+                <a:latin typeface="Calibri"/>
+              </a:rPr>
+              <a:t>Applying that ~0.95-0.98 ratio (not the old 0.80) to the 0.75mm-arm FEA (81.35Hz, 90.55Hz, below) gives a revised estimate of ~79-86Hz — close to raw FEA, not the ~65/72Hz previously stated.</a:t>
             </a:r>
           </a:p>
           <a:p>
             <a:pPr>
               <a:spcAft>
-                <a:spcPts val="900"/>
+                <a:spcPts val="600"/>
               </a:spcAft>
             </a:pPr>
             <a:r>
-              <a:rPr sz="1250">
+              <a:rPr sz="1150">
                 <a:solidFill>
                   <a:srgbClr val="333333"/>
                 </a:solidFill>
@@ -5448,23 +5473,23 @@
               <a:t>• </a:t>
             </a:r>
             <a:r>
-              <a:rPr sz="1250">
-                <a:solidFill>
-                  <a:srgbClr val="333333"/>
-                </a:solidFill>
-                <a:latin typeface="Calibri"/>
-              </a:rPr>
-              <a:t>Applying that 0.80 correction to the just-ordered 0.75mm-arm FEA (mode 1 = 81.35Hz, mode 2 = 90.55Hz, below) gives a revised bench estimate of ~65Hz / ~72Hz, not the raw FEA numbers.</a:t>
+              <a:rPr sz="1150">
+                <a:solidFill>
+                  <a:srgbClr val="333333"/>
+                </a:solidFill>
+                <a:latin typeface="Calibri"/>
+              </a:rPr>
+              <a:t>Against the 20Hz PID target that's ~4x margin, not the more pessimistic 3.25x previously concluded here — close to what raw FEA always suggested.</a:t>
             </a:r>
           </a:p>
           <a:p>
             <a:pPr>
               <a:spcAft>
-                <a:spcPts val="900"/>
+                <a:spcPts val="600"/>
               </a:spcAft>
             </a:pPr>
             <a:r>
-              <a:rPr sz="1250">
+              <a:rPr sz="1150">
                 <a:solidFill>
                   <a:srgbClr val="333333"/>
                 </a:solidFill>
@@ -5473,47 +5498,22 @@
               <a:t>• </a:t>
             </a:r>
             <a:r>
-              <a:rPr sz="1250">
-                <a:solidFill>
-                  <a:srgbClr val="333333"/>
-                </a:solidFill>
-                <a:latin typeface="Calibri"/>
-              </a:rPr>
-              <a:t>Against the 20Hz PID target that's ~3.25x margin corrected vs. 4.1x from raw FEA — still a real win over today's ~1.9x (38.5Hz/20Hz), just less headroom than FEA alone suggested.</a:t>
-            </a:r>
-          </a:p>
-          <a:p>
-            <a:pPr>
-              <a:spcAft>
-                <a:spcPts val="900"/>
-              </a:spcAft>
-            </a:pPr>
-            <a:r>
-              <a:rPr sz="1250">
-                <a:solidFill>
-                  <a:srgbClr val="333333"/>
-                </a:solidFill>
-                <a:latin typeface="Calibri"/>
-              </a:rPr>
-              <a:t>• </a:t>
-            </a:r>
-            <a:r>
-              <a:rPr sz="1250" b="1">
-                <a:solidFill>
-                  <a:srgbClr val="333333"/>
-                </a:solidFill>
-                <a:latin typeface="Calibri"/>
-              </a:rPr>
-              <a:t>Action: </a:t>
-            </a:r>
-            <a:r>
-              <a:rPr sz="1250">
-                <a:solidFill>
-                  <a:srgbClr val="333333"/>
-                </a:solidFill>
-                <a:latin typeface="Calibri"/>
-              </a:rPr>
-              <a:t>rerun the bode sweep and ring-down test on the 0.75mm part once installed to confirm directly, rather than relying on the scaled estimate.</a:t>
+              <a:rPr sz="1150" b="1">
+                <a:solidFill>
+                  <a:srgbClr val="333333"/>
+                </a:solidFill>
+                <a:latin typeface="Calibri"/>
+              </a:rPr>
+              <a:t>Open questions: </a:t>
+            </a:r>
+            <a:r>
+              <a:rPr sz="1150">
+                <a:solidFill>
+                  <a:srgbClr val="333333"/>
+                </a:solidFill>
+                <a:latin typeface="Calibri"/>
+              </a:rPr>
+              <a:t>physical cause of the shift unidentified; y-axis has only 1 trial vs. x's 2. Action unchanged: rerun bode + ring-down on the actual 0.75mm part once installed.</a:t>
             </a:r>
           </a:p>
         </p:txBody>
@@ -6206,7 +6206,7 @@
                 </a:solidFill>
                 <a:latin typeface="Calibri"/>
               </a:rPr>
-              <a:t>First six modes from the SOLUTION 1 real-eigenvalue tables (main_flexure_v3 / PCB_FTA_assembly .f06 results). Bench-measured resonance for the 0.5mm part is 38.5Hz — see previous slide for the FEA-vs-bench correction.</a:t>
+              <a:t>First six modes from the SOLUTION 1 real-eigenvalue tables (main_flexure_v3 / PCB_FTA_assembly .f06 results). Bench-measured resonance for the 0.5mm part: 47.0-47.3Hz (x-axis) / 50.1Hz (y-axis), re-measured after fixing ring-down timing bugs (originally 38.5Hz) — see previous slide.</a:t>
             </a:r>
           </a:p>
         </p:txBody>

</xml_diff>

<commit_message>
docs: add ring-down plots slide before the FEA-vs-bench comparison slide
</commit_message>
<xml_diff>
--- a/docs/session_results_2026-08-18_pid_tuning.pptx
+++ b/docs/session_results_2026-08-18_pid_tuning.pptx
@@ -25,6 +25,7 @@
     <p:sldId id="277" r:id="rId24"/>
     <p:sldId id="274" r:id="rId21"/>
     <p:sldId id="273" r:id="rId20"/>
+    <p:sldId id="278" r:id="rId25"/>
     <p:sldId id="275" r:id="rId22"/>
     <p:sldId id="276" r:id="rId23"/>
   </p:sldIdLst>
@@ -6219,6 +6220,368 @@
 </p:sld>
 </file>
 
+<file path=ppt/slides/slide24.xml><?xml version="1.0" encoding="utf-8"?>
+<p:sld xmlns:a="http://schemas.openxmlformats.org/drawingml/2006/main" xmlns:p="http://schemas.openxmlformats.org/presentationml/2006/main" xmlns:r="http://schemas.openxmlformats.org/officeDocument/2006/relationships">
+  <p:cSld>
+    <p:spTree>
+      <p:nvGrpSpPr>
+        <p:cNvPr id="1" name=""/>
+        <p:cNvGrpSpPr/>
+        <p:nvPr/>
+      </p:nvGrpSpPr>
+      <p:grpSpPr/>
+      <p:sp>
+        <p:nvSpPr>
+          <p:cNvPr id="2" name="TextBox 1"/>
+          <p:cNvSpPr txBox="1"/>
+          <p:nvPr/>
+        </p:nvSpPr>
+        <p:spPr>
+          <a:xfrm>
+            <a:off x="457200" y="228600"/>
+            <a:ext cx="11246760" cy="486360"/>
+          </a:xfrm>
+          <a:prstGeom prst="rect">
+            <a:avLst/>
+          </a:prstGeom>
+          <a:noFill/>
+        </p:spPr>
+        <p:txBody>
+          <a:bodyPr wrap="square">
+            <a:spAutoFit/>
+          </a:bodyPr>
+          <a:lstStyle/>
+          <a:p>
+            <a:r>
+              <a:rPr sz="2400" b="1">
+                <a:solidFill>
+                  <a:srgbClr val="1A1A2E"/>
+                </a:solidFill>
+                <a:latin typeface="Calibri"/>
+              </a:rPr>
+              <a:t>New ring-down measurements, both axes — the resonance behind the updated FEA comparison</a:t>
+            </a:r>
+          </a:p>
+        </p:txBody>
+      </p:sp>
+      <p:cxnSp>
+        <p:nvCxnSpPr>
+          <p:cNvPr id="3" name="Connector 2"/>
+          <p:cNvCxnSpPr/>
+          <p:nvPr/>
+        </p:nvCxnSpPr>
+        <p:spPr>
+          <a:xfrm>
+            <a:off x="457200" y="960120"/>
+            <a:ext cx="11247120" cy="0"/>
+          </a:xfrm>
+          <a:prstGeom prst="line">
+            <a:avLst/>
+          </a:prstGeom>
+          <a:ln w="19080">
+            <a:solidFill>
+              <a:srgbClr val="2E5C8A"/>
+            </a:solidFill>
+          </a:ln>
+        </p:spPr>
+        <p:style>
+          <a:lnRef idx="2">
+            <a:schemeClr val="accent1"/>
+          </a:lnRef>
+          <a:fillRef idx="0">
+            <a:schemeClr val="accent1"/>
+          </a:fillRef>
+          <a:effectRef idx="1">
+            <a:schemeClr val="accent1"/>
+          </a:effectRef>
+          <a:fontRef idx="minor">
+            <a:schemeClr val="tx1"/>
+          </a:fontRef>
+        </p:style>
+      </p:cxnSp>
+      <p:sp>
+        <p:nvSpPr>
+          <p:cNvPr id="4" name="TextBox 3"/>
+          <p:cNvSpPr txBox="1"/>
+          <p:nvPr/>
+        </p:nvSpPr>
+        <p:spPr>
+          <a:xfrm>
+            <a:off x="457200" y="1080000"/>
+            <a:ext cx="11246760" cy="500000"/>
+          </a:xfrm>
+          <a:prstGeom prst="rect">
+            <a:avLst/>
+          </a:prstGeom>
+          <a:noFill/>
+        </p:spPr>
+        <p:txBody>
+          <a:bodyPr wrap="square">
+            <a:spAutoFit/>
+          </a:bodyPr>
+          <a:lstStyle/>
+          <a:p>
+            <a:r>
+              <a:rPr sz="1250">
+                <a:solidFill>
+                  <a:srgbClr val="333333"/>
+                </a:solidFill>
+                <a:latin typeface="Calibri"/>
+              </a:rPr>
+              <a:t>Model-free peak-spacing estimate (dashed curve_fit overlay is unreliable — see annotation on each plot); tick-timestamped, same method as the original 38.5Hz measurement.</a:t>
+            </a:r>
+          </a:p>
+        </p:txBody>
+      </p:sp>
+      <p:pic>
+        <p:nvPicPr>
+          <p:cNvPr id="5" name="Picture 4" descr="fta_ringdown_xaxis_20260828T003210Z.png"/>
+          <p:cNvPicPr>
+            <a:picLocks noChangeAspect="1"/>
+          </p:cNvPicPr>
+          <p:nvPr/>
+        </p:nvPicPr>
+        <p:blipFill>
+          <a:blip r:embed="rId2"/>
+          <a:stretch>
+            <a:fillRect/>
+          </a:stretch>
+        </p:blipFill>
+        <p:spPr>
+          <a:xfrm>
+            <a:off x="457200" y="1650000"/>
+            <a:ext cx="3595587" cy="1618000"/>
+          </a:xfrm>
+          <a:prstGeom prst="rect">
+            <a:avLst/>
+          </a:prstGeom>
+        </p:spPr>
+      </p:pic>
+      <p:pic>
+        <p:nvPicPr>
+          <p:cNvPr id="6" name="Picture 5" descr="fta_ringdown_xaxis_20260828T003754Z.png"/>
+          <p:cNvPicPr>
+            <a:picLocks noChangeAspect="1"/>
+          </p:cNvPicPr>
+          <p:nvPr/>
+        </p:nvPicPr>
+        <p:blipFill>
+          <a:blip r:embed="rId3"/>
+          <a:stretch>
+            <a:fillRect/>
+          </a:stretch>
+        </p:blipFill>
+        <p:spPr>
+          <a:xfrm>
+            <a:off x="4282787" y="1650000"/>
+            <a:ext cx="3595587" cy="1618000"/>
+          </a:xfrm>
+          <a:prstGeom prst="rect">
+            <a:avLst/>
+          </a:prstGeom>
+        </p:spPr>
+      </p:pic>
+      <p:pic>
+        <p:nvPicPr>
+          <p:cNvPr id="7" name="Picture 6" descr="fta_ringdown_yaxis_20260828T003403Z_fixed.png"/>
+          <p:cNvPicPr>
+            <a:picLocks noChangeAspect="1"/>
+          </p:cNvPicPr>
+          <p:nvPr/>
+        </p:nvPicPr>
+        <p:blipFill>
+          <a:blip r:embed="rId4"/>
+          <a:stretch>
+            <a:fillRect/>
+          </a:stretch>
+        </p:blipFill>
+        <p:spPr>
+          <a:xfrm>
+            <a:off x="8108374" y="1650000"/>
+            <a:ext cx="3595587" cy="1618000"/>
+          </a:xfrm>
+          <a:prstGeom prst="rect">
+            <a:avLst/>
+          </a:prstGeom>
+        </p:spPr>
+      </p:pic>
+      <p:sp>
+        <p:nvSpPr>
+          <p:cNvPr id="8" name="Caption 1"/>
+          <p:cNvSpPr txBox="1"/>
+          <p:nvPr/>
+        </p:nvSpPr>
+        <p:spPr>
+          <a:xfrm>
+            <a:off x="457200" y="3330000"/>
+            <a:ext cx="3595587" cy="700000"/>
+          </a:xfrm>
+          <a:prstGeom prst="rect">
+            <a:avLst/>
+          </a:prstGeom>
+          <a:noFill/>
+        </p:spPr>
+        <p:txBody>
+          <a:bodyPr wrap="square">
+            <a:spAutoFit/>
+          </a:bodyPr>
+          <a:lstStyle/>
+          <a:p>
+            <a:r>
+              <a:rPr sz="1150" b="1">
+                <a:solidFill>
+                  <a:srgbClr val="333333"/>
+                </a:solidFill>
+                <a:latin typeface="Calibri"/>
+              </a:rPr>
+              <a:t>X-axis, trial 1: 47.3Hz</a:t>
+            </a:r>
+          </a:p>
+          <a:p>
+            <a:r>
+              <a:rPr sz="1050">
+                <a:solidFill>
+                  <a:srgbClr val="666666"/>
+                </a:solidFill>
+                <a:latin typeface="Calibri"/>
+              </a:rPr>
+              <a:t>dac_y→cx, primary axis</a:t>
+            </a:r>
+          </a:p>
+        </p:txBody>
+      </p:sp>
+      <p:sp>
+        <p:nvSpPr>
+          <p:cNvPr id="9" name="Caption 2"/>
+          <p:cNvSpPr txBox="1"/>
+          <p:nvPr/>
+        </p:nvSpPr>
+        <p:spPr>
+          <a:xfrm>
+            <a:off x="4282787" y="3330000"/>
+            <a:ext cx="3595587" cy="700000"/>
+          </a:xfrm>
+          <a:prstGeom prst="rect">
+            <a:avLst/>
+          </a:prstGeom>
+          <a:noFill/>
+        </p:spPr>
+        <p:txBody>
+          <a:bodyPr wrap="square">
+            <a:spAutoFit/>
+          </a:bodyPr>
+          <a:lstStyle/>
+          <a:p>
+            <a:r>
+              <a:rPr sz="1150" b="1">
+                <a:solidFill>
+                  <a:srgbClr val="333333"/>
+                </a:solidFill>
+                <a:latin typeface="Calibri"/>
+              </a:rPr>
+              <a:t>X-axis, trial 2 (immediate repeat): 47.0Hz</a:t>
+            </a:r>
+          </a:p>
+          <a:p>
+            <a:r>
+              <a:rPr sz="1050">
+                <a:solidFill>
+                  <a:srgbClr val="666666"/>
+                </a:solidFill>
+                <a:latin typeface="Calibri"/>
+              </a:rPr>
+              <a:t>dac_y→cx — tight agreement with trial 1</a:t>
+            </a:r>
+          </a:p>
+        </p:txBody>
+      </p:sp>
+      <p:sp>
+        <p:nvSpPr>
+          <p:cNvPr id="10" name="Caption 3"/>
+          <p:cNvSpPr txBox="1"/>
+          <p:nvPr/>
+        </p:nvSpPr>
+        <p:spPr>
+          <a:xfrm>
+            <a:off x="8108374" y="3330000"/>
+            <a:ext cx="3595587" cy="700000"/>
+          </a:xfrm>
+          <a:prstGeom prst="rect">
+            <a:avLst/>
+          </a:prstGeom>
+          <a:noFill/>
+        </p:spPr>
+        <p:txBody>
+          <a:bodyPr wrap="square">
+            <a:spAutoFit/>
+          </a:bodyPr>
+          <a:lstStyle/>
+          <a:p>
+            <a:r>
+              <a:rPr sz="1150" b="1">
+                <a:solidFill>
+                  <a:srgbClr val="333333"/>
+                </a:solidFill>
+                <a:latin typeface="Calibri"/>
+              </a:rPr>
+              <a:t>Y-axis, first-ever trial: 50.1Hz</a:t>
+            </a:r>
+          </a:p>
+          <a:p>
+            <a:r>
+              <a:rPr sz="1050">
+                <a:solidFill>
+                  <a:srgbClr val="666666"/>
+                </a:solidFill>
+                <a:latin typeface="Calibri"/>
+              </a:rPr>
+              <a:t>dac_x→cy — only one trial so far</a:t>
+            </a:r>
+          </a:p>
+        </p:txBody>
+      </p:sp>
+      <p:sp>
+        <p:nvSpPr>
+          <p:cNvPr id="11" name="Note"/>
+          <p:cNvSpPr txBox="1"/>
+          <p:nvPr/>
+        </p:nvSpPr>
+        <p:spPr>
+          <a:xfrm>
+            <a:off x="457200" y="4200000"/>
+            <a:ext cx="11246760" cy="700000"/>
+          </a:xfrm>
+          <a:prstGeom prst="rect">
+            <a:avLst/>
+          </a:prstGeom>
+          <a:noFill/>
+        </p:spPr>
+        <p:txBody>
+          <a:bodyPr wrap="square">
+            <a:spAutoFit/>
+          </a:bodyPr>
+          <a:lstStyle/>
+          <a:p>
+            <a:r>
+              <a:rPr sz="1150" i="1">
+                <a:solidFill>
+                  <a:srgbClr val="555555"/>
+                </a:solidFill>
+                <a:latin typeface="Calibri"/>
+              </a:rPr>
+              <a:t>Both axes land close to each other and notably not close to the previously-documented 38.5Hz. Same trustworthy tick-timestamped peak-spacing method as the original measurement, so this reads as a real, reproducible shift in the physical resonance since then — see next slide for the updated FEA comparison.</a:t>
+            </a:r>
+          </a:p>
+        </p:txBody>
+      </p:sp>
+    </p:spTree>
+  </p:cSld>
+  <p:clrMapOvr>
+    <a:masterClrMapping/>
+  </p:clrMapOvr>
+</p:sld>
+</file>
+
 <file path=ppt/slides/slide3.xml><?xml version="1.0" encoding="utf-8"?>
 <p:sld xmlns:a="http://schemas.openxmlformats.org/drawingml/2006/main" xmlns:p="http://schemas.openxmlformats.org/presentationml/2006/main" xmlns:r="http://schemas.openxmlformats.org/officeDocument/2006/relationships" xmlns:p14="http://schemas.microsoft.com/office/powerpoint/2010/main" xmlns:p15="http://schemas.microsoft.com/office/powerpoint/2012/main" xmlns:mc="http://schemas.openxmlformats.org/markup-compatibility/2006">
   <p:cSld>

</xml_diff>

<commit_message>
docs: add I2C link-completeness and control-step jitter slides (on top of the merged FEA-vs-bench deck)
Co-Authored-By: Claude Sonnet 5 <noreply@anthropic.com>
</commit_message>
<xml_diff>
--- a/docs/session_results_2026-08-18_pid_tuning.pptx
+++ b/docs/session_results_2026-08-18_pid_tuning.pptx
@@ -28,6 +28,8 @@
     <p:sldId id="278" r:id="rId25"/>
     <p:sldId id="275" r:id="rId22"/>
     <p:sldId id="276" r:id="rId23"/>
+    <p:sldId id="279" r:id="rId26"/>
+    <p:sldId id="280" r:id="rId27"/>
   </p:sldIdLst>
   <p:sldSz cx="12192000" cy="6858000"/>
   <p:notesSz cx="7772400" cy="10058400"/>
@@ -4321,6 +4323,290 @@
 </p:sld>
 </file>
 
+<file path=ppt/slides/slide19.xml><?xml version="1.0" encoding="utf-8"?>
+<p:sld xmlns:a="http://schemas.openxmlformats.org/drawingml/2006/main" xmlns:p="http://schemas.openxmlformats.org/presentationml/2006/main" xmlns:r="http://schemas.openxmlformats.org/officeDocument/2006/relationships">
+  <p:cSld>
+    <p:spTree>
+      <p:nvGrpSpPr>
+        <p:cNvPr id="1" name=""/>
+        <p:cNvGrpSpPr/>
+        <p:nvPr/>
+      </p:nvGrpSpPr>
+      <p:grpSpPr/>
+      <p:sp>
+        <p:nvSpPr>
+          <p:cNvPr id="2" name="TextBox 1"/>
+          <p:cNvSpPr txBox="1"/>
+          <p:nvPr/>
+        </p:nvSpPr>
+        <p:spPr>
+          <a:xfrm>
+            <a:off x="457200" y="228600"/>
+            <a:ext cx="11246760" cy="486360"/>
+          </a:xfrm>
+          <a:prstGeom prst="rect">
+            <a:avLst/>
+          </a:prstGeom>
+          <a:noFill/>
+        </p:spPr>
+        <p:txBody>
+          <a:bodyPr wrap="square">
+            <a:spAutoFit/>
+          </a:bodyPr>
+          <a:lstStyle/>
+          <a:p>
+            <a:r>
+              <a:rPr sz="2400" b="1">
+                <a:solidFill>
+                  <a:srgbClr val="1A1A2E"/>
+                </a:solidFill>
+                <a:latin typeface="Calibri"/>
+              </a:rPr>
+              <a:t>Open-loop plant Bode plot — the resonance, not delay or tuning, is the ceiling</a:t>
+            </a:r>
+          </a:p>
+        </p:txBody>
+      </p:sp>
+      <p:cxnSp>
+        <p:nvCxnSpPr>
+          <p:cNvPr id="3" name="Connector 2"/>
+          <p:cNvCxnSpPr/>
+          <p:nvPr/>
+        </p:nvCxnSpPr>
+        <p:spPr>
+          <a:xfrm>
+            <a:off x="457200" y="960120"/>
+            <a:ext cx="11247120" cy="0"/>
+          </a:xfrm>
+          <a:prstGeom prst="line">
+            <a:avLst/>
+          </a:prstGeom>
+          <a:ln w="19080">
+            <a:solidFill>
+              <a:srgbClr val="2E5C8A"/>
+            </a:solidFill>
+          </a:ln>
+        </p:spPr>
+        <p:style>
+          <a:lnRef idx="2">
+            <a:schemeClr val="accent1"/>
+          </a:lnRef>
+          <a:fillRef idx="0">
+            <a:schemeClr val="accent1"/>
+          </a:fillRef>
+          <a:effectRef idx="1">
+            <a:schemeClr val="accent1"/>
+          </a:effectRef>
+          <a:fontRef idx="minor">
+            <a:schemeClr val="tx1"/>
+          </a:fontRef>
+        </p:style>
+      </p:cxnSp>
+      <p:sp>
+        <p:nvSpPr>
+          <p:cNvPr id="4" name="TextBox 3"/>
+          <p:cNvSpPr txBox="1"/>
+          <p:nvPr/>
+        </p:nvSpPr>
+        <p:spPr>
+          <a:xfrm>
+            <a:off x="457200" y="1143000"/>
+            <a:ext cx="5577480" cy="3565800"/>
+          </a:xfrm>
+          <a:prstGeom prst="rect">
+            <a:avLst/>
+          </a:prstGeom>
+          <a:noFill/>
+        </p:spPr>
+        <p:txBody>
+          <a:bodyPr wrap="square">
+            <a:spAutoFit/>
+          </a:bodyPr>
+          <a:lstStyle/>
+          <a:p>
+            <a:pPr>
+              <a:spcAft>
+                <a:spcPts val="900"/>
+              </a:spcAft>
+            </a:pPr>
+            <a:r>
+              <a:rPr sz="1250">
+                <a:solidFill>
+                  <a:srgbClr val="333333"/>
+                </a:solidFill>
+                <a:latin typeface="Calibri"/>
+              </a:rPr>
+              <a:t>• </a:t>
+            </a:r>
+            <a:r>
+              <a:rPr sz="1250">
+                <a:solidFill>
+                  <a:srgbClr val="333333"/>
+                </a:solidFill>
+                <a:latin typeface="Calibri"/>
+              </a:rPr>
+              <a:t>Built a firmware open-loop sine generator (bypasses the PID entirely, drives dac_y directly) and swept dac_y→cx across 1-50Hz — the first real open-loop frequency response measured this project.</a:t>
+            </a:r>
+          </a:p>
+          <a:p>
+            <a:pPr>
+              <a:spcAft>
+                <a:spcPts val="900"/>
+              </a:spcAft>
+            </a:pPr>
+            <a:r>
+              <a:rPr sz="1250">
+                <a:solidFill>
+                  <a:srgbClr val="333333"/>
+                </a:solidFill>
+                <a:latin typeface="Calibri"/>
+              </a:rPr>
+              <a:t>• </a:t>
+            </a:r>
+            <a:r>
+              <a:rPr sz="1250">
+                <a:solidFill>
+                  <a:srgbClr val="333333"/>
+                </a:solidFill>
+                <a:latin typeface="Calibri"/>
+              </a:rPr>
+              <a:t>Phase has real margin through 10-20Hz (40° at 10Hz, 79° at 20Hz) — the plant itself isn't the problem IN that band.</a:t>
+            </a:r>
+          </a:p>
+          <a:p>
+            <a:pPr>
+              <a:spcAft>
+                <a:spcPts val="900"/>
+              </a:spcAft>
+            </a:pPr>
+            <a:r>
+              <a:rPr sz="1250">
+                <a:solidFill>
+                  <a:srgbClr val="333333"/>
+                </a:solidFill>
+                <a:latin typeface="Calibri"/>
+              </a:rPr>
+              <a:t>• </a:t>
+            </a:r>
+            <a:r>
+              <a:rPr sz="1250">
+                <a:solidFill>
+                  <a:srgbClr val="333333"/>
+                </a:solidFill>
+                <a:latin typeface="Calibri"/>
+              </a:rPr>
+              <a:t>Sharp resonance at 38.5Hz (gain ~7.6x DC) — matches the ring-down test exactly, from a completely independent method (forced sine vs. free decay). Strong cross-validation, not a fluke.</a:t>
+            </a:r>
+          </a:p>
+          <a:p>
+            <a:pPr>
+              <a:spcAft>
+                <a:spcPts val="900"/>
+              </a:spcAft>
+            </a:pPr>
+            <a:r>
+              <a:rPr sz="1250">
+                <a:solidFill>
+                  <a:srgbClr val="333333"/>
+                </a:solidFill>
+                <a:latin typeface="Calibri"/>
+              </a:rPr>
+              <a:t>• </a:t>
+            </a:r>
+            <a:r>
+              <a:rPr sz="1250">
+                <a:solidFill>
+                  <a:srgbClr val="333333"/>
+                </a:solidFill>
+                <a:latin typeface="Calibri"/>
+              </a:rPr>
+              <a:t>5Hz lag (12.0ms) matches the directly-measured pure loop delay (~11.5ms) — a third independent cross-check.</a:t>
+            </a:r>
+          </a:p>
+          <a:p>
+            <a:pPr>
+              <a:spcAft>
+                <a:spcPts val="900"/>
+              </a:spcAft>
+            </a:pPr>
+            <a:r>
+              <a:rPr sz="1250">
+                <a:solidFill>
+                  <a:srgbClr val="333333"/>
+                </a:solidFill>
+                <a:latin typeface="Calibri"/>
+              </a:rPr>
+              <a:t>• </a:t>
+            </a:r>
+            <a:r>
+              <a:rPr sz="1250">
+                <a:solidFill>
+                  <a:srgbClr val="333333"/>
+                </a:solidFill>
+                <a:latin typeface="Calibri"/>
+              </a:rPr>
+              <a:t>Any Ki high enough to push gain-crossover toward ~20-25Hz+ runs into the resonance's fast phase rotation (~140° in under two octaves) — explains the hard Ki ceiling all session, and why the notch's narrow fix gave a mixed result (previous slide).</a:t>
+            </a:r>
+          </a:p>
+          <a:p>
+            <a:pPr>
+              <a:spcAft>
+                <a:spcPts val="900"/>
+              </a:spcAft>
+            </a:pPr>
+            <a:r>
+              <a:rPr sz="1250">
+                <a:solidFill>
+                  <a:srgbClr val="333333"/>
+                </a:solidFill>
+                <a:latin typeface="Calibri"/>
+              </a:rPr>
+              <a:t>• </a:t>
+            </a:r>
+            <a:r>
+              <a:rPr sz="1250">
+                <a:solidFill>
+                  <a:srgbClr val="333333"/>
+                </a:solidFill>
+                <a:latin typeface="Calibri"/>
+              </a:rPr>
+              <a:t>Strongest evidence yet for a hardware fix (stiffen/damp the flexure) over continued controller tuning.</a:t>
+            </a:r>
+          </a:p>
+        </p:txBody>
+      </p:sp>
+      <p:pic>
+        <p:nvPicPr>
+          <p:cNvPr id="5" name="Picture 4" descr="fta_open_loop_bode_summary.png"/>
+          <p:cNvPicPr>
+            <a:picLocks noChangeAspect="1"/>
+          </p:cNvPicPr>
+          <p:nvPr/>
+        </p:nvPicPr>
+        <p:blipFill>
+          <a:blip r:embed="rId3"/>
+          <a:stretch>
+            <a:fillRect/>
+          </a:stretch>
+        </p:blipFill>
+        <p:spPr>
+          <a:xfrm>
+            <a:off x="7031760" y="1143000"/>
+            <a:ext cx="4041240" cy="3565800"/>
+          </a:xfrm>
+          <a:prstGeom prst="rect">
+            <a:avLst/>
+          </a:prstGeom>
+        </p:spPr>
+      </p:pic>
+    </p:spTree>
+  </p:cSld>
+  <p:clrMapOvr>
+    <a:masterClrMapping/>
+  </p:clrMapOvr>
+</p:sld>
+</file>
+
 <file path=ppt/slides/slide2.xml><?xml version="1.0" encoding="utf-8"?>
 <p:sld xmlns:a="http://schemas.openxmlformats.org/drawingml/2006/main" xmlns:p="http://schemas.openxmlformats.org/presentationml/2006/main" xmlns:r="http://schemas.openxmlformats.org/officeDocument/2006/relationships" xmlns:p14="http://schemas.microsoft.com/office/powerpoint/2010/main" xmlns:p15="http://schemas.microsoft.com/office/powerpoint/2012/main" xmlns:mc="http://schemas.openxmlformats.org/markup-compatibility/2006">
   <p:cSld>
@@ -4627,290 +4913,6 @@
 </file>
 
 <file path=ppt/slides/slide20.xml><?xml version="1.0" encoding="utf-8"?>
-<p:sld xmlns:a="http://schemas.openxmlformats.org/drawingml/2006/main" xmlns:p="http://schemas.openxmlformats.org/presentationml/2006/main" xmlns:r="http://schemas.openxmlformats.org/officeDocument/2006/relationships">
-  <p:cSld>
-    <p:spTree>
-      <p:nvGrpSpPr>
-        <p:cNvPr id="1" name=""/>
-        <p:cNvGrpSpPr/>
-        <p:nvPr/>
-      </p:nvGrpSpPr>
-      <p:grpSpPr/>
-      <p:sp>
-        <p:nvSpPr>
-          <p:cNvPr id="2" name="TextBox 1"/>
-          <p:cNvSpPr txBox="1"/>
-          <p:nvPr/>
-        </p:nvSpPr>
-        <p:spPr>
-          <a:xfrm>
-            <a:off x="457200" y="228600"/>
-            <a:ext cx="11246760" cy="486360"/>
-          </a:xfrm>
-          <a:prstGeom prst="rect">
-            <a:avLst/>
-          </a:prstGeom>
-          <a:noFill/>
-        </p:spPr>
-        <p:txBody>
-          <a:bodyPr wrap="square">
-            <a:spAutoFit/>
-          </a:bodyPr>
-          <a:lstStyle/>
-          <a:p>
-            <a:r>
-              <a:rPr sz="2400" b="1">
-                <a:solidFill>
-                  <a:srgbClr val="1A1A2E"/>
-                </a:solidFill>
-                <a:latin typeface="Calibri"/>
-              </a:rPr>
-              <a:t>Open-loop plant Bode plot — the resonance, not delay or tuning, is the ceiling</a:t>
-            </a:r>
-          </a:p>
-        </p:txBody>
-      </p:sp>
-      <p:cxnSp>
-        <p:nvCxnSpPr>
-          <p:cNvPr id="3" name="Connector 2"/>
-          <p:cNvCxnSpPr/>
-          <p:nvPr/>
-        </p:nvCxnSpPr>
-        <p:spPr>
-          <a:xfrm>
-            <a:off x="457200" y="960120"/>
-            <a:ext cx="11247120" cy="0"/>
-          </a:xfrm>
-          <a:prstGeom prst="line">
-            <a:avLst/>
-          </a:prstGeom>
-          <a:ln w="19080">
-            <a:solidFill>
-              <a:srgbClr val="2E5C8A"/>
-            </a:solidFill>
-          </a:ln>
-        </p:spPr>
-        <p:style>
-          <a:lnRef idx="2">
-            <a:schemeClr val="accent1"/>
-          </a:lnRef>
-          <a:fillRef idx="0">
-            <a:schemeClr val="accent1"/>
-          </a:fillRef>
-          <a:effectRef idx="1">
-            <a:schemeClr val="accent1"/>
-          </a:effectRef>
-          <a:fontRef idx="minor">
-            <a:schemeClr val="tx1"/>
-          </a:fontRef>
-        </p:style>
-      </p:cxnSp>
-      <p:sp>
-        <p:nvSpPr>
-          <p:cNvPr id="4" name="TextBox 3"/>
-          <p:cNvSpPr txBox="1"/>
-          <p:nvPr/>
-        </p:nvSpPr>
-        <p:spPr>
-          <a:xfrm>
-            <a:off x="457200" y="1143000"/>
-            <a:ext cx="5577480" cy="3565800"/>
-          </a:xfrm>
-          <a:prstGeom prst="rect">
-            <a:avLst/>
-          </a:prstGeom>
-          <a:noFill/>
-        </p:spPr>
-        <p:txBody>
-          <a:bodyPr wrap="square">
-            <a:spAutoFit/>
-          </a:bodyPr>
-          <a:lstStyle/>
-          <a:p>
-            <a:pPr>
-              <a:spcAft>
-                <a:spcPts val="900"/>
-              </a:spcAft>
-            </a:pPr>
-            <a:r>
-              <a:rPr sz="1250">
-                <a:solidFill>
-                  <a:srgbClr val="333333"/>
-                </a:solidFill>
-                <a:latin typeface="Calibri"/>
-              </a:rPr>
-              <a:t>• </a:t>
-            </a:r>
-            <a:r>
-              <a:rPr sz="1250">
-                <a:solidFill>
-                  <a:srgbClr val="333333"/>
-                </a:solidFill>
-                <a:latin typeface="Calibri"/>
-              </a:rPr>
-              <a:t>Built a firmware open-loop sine generator (bypasses the PID entirely, drives dac_y directly) and swept dac_y→cx across 1-50Hz — the first real open-loop frequency response measured this project.</a:t>
-            </a:r>
-          </a:p>
-          <a:p>
-            <a:pPr>
-              <a:spcAft>
-                <a:spcPts val="900"/>
-              </a:spcAft>
-            </a:pPr>
-            <a:r>
-              <a:rPr sz="1250">
-                <a:solidFill>
-                  <a:srgbClr val="333333"/>
-                </a:solidFill>
-                <a:latin typeface="Calibri"/>
-              </a:rPr>
-              <a:t>• </a:t>
-            </a:r>
-            <a:r>
-              <a:rPr sz="1250">
-                <a:solidFill>
-                  <a:srgbClr val="333333"/>
-                </a:solidFill>
-                <a:latin typeface="Calibri"/>
-              </a:rPr>
-              <a:t>Phase has real margin through 10-20Hz (40° at 10Hz, 79° at 20Hz) — the plant itself isn't the problem IN that band.</a:t>
-            </a:r>
-          </a:p>
-          <a:p>
-            <a:pPr>
-              <a:spcAft>
-                <a:spcPts val="900"/>
-              </a:spcAft>
-            </a:pPr>
-            <a:r>
-              <a:rPr sz="1250">
-                <a:solidFill>
-                  <a:srgbClr val="333333"/>
-                </a:solidFill>
-                <a:latin typeface="Calibri"/>
-              </a:rPr>
-              <a:t>• </a:t>
-            </a:r>
-            <a:r>
-              <a:rPr sz="1250">
-                <a:solidFill>
-                  <a:srgbClr val="333333"/>
-                </a:solidFill>
-                <a:latin typeface="Calibri"/>
-              </a:rPr>
-              <a:t>Sharp resonance at 38.5Hz (gain ~7.6x DC) — matches the ring-down test exactly, from a completely independent method (forced sine vs. free decay). Strong cross-validation, not a fluke.</a:t>
-            </a:r>
-          </a:p>
-          <a:p>
-            <a:pPr>
-              <a:spcAft>
-                <a:spcPts val="900"/>
-              </a:spcAft>
-            </a:pPr>
-            <a:r>
-              <a:rPr sz="1250">
-                <a:solidFill>
-                  <a:srgbClr val="333333"/>
-                </a:solidFill>
-                <a:latin typeface="Calibri"/>
-              </a:rPr>
-              <a:t>• </a:t>
-            </a:r>
-            <a:r>
-              <a:rPr sz="1250">
-                <a:solidFill>
-                  <a:srgbClr val="333333"/>
-                </a:solidFill>
-                <a:latin typeface="Calibri"/>
-              </a:rPr>
-              <a:t>5Hz lag (12.0ms) matches the directly-measured pure loop delay (~11.5ms) — a third independent cross-check.</a:t>
-            </a:r>
-          </a:p>
-          <a:p>
-            <a:pPr>
-              <a:spcAft>
-                <a:spcPts val="900"/>
-              </a:spcAft>
-            </a:pPr>
-            <a:r>
-              <a:rPr sz="1250">
-                <a:solidFill>
-                  <a:srgbClr val="333333"/>
-                </a:solidFill>
-                <a:latin typeface="Calibri"/>
-              </a:rPr>
-              <a:t>• </a:t>
-            </a:r>
-            <a:r>
-              <a:rPr sz="1250">
-                <a:solidFill>
-                  <a:srgbClr val="333333"/>
-                </a:solidFill>
-                <a:latin typeface="Calibri"/>
-              </a:rPr>
-              <a:t>Any Ki high enough to push gain-crossover toward ~20-25Hz+ runs into the resonance's fast phase rotation (~140° in under two octaves) — explains the hard Ki ceiling all session, and why the notch's narrow fix gave a mixed result (previous slide).</a:t>
-            </a:r>
-          </a:p>
-          <a:p>
-            <a:pPr>
-              <a:spcAft>
-                <a:spcPts val="900"/>
-              </a:spcAft>
-            </a:pPr>
-            <a:r>
-              <a:rPr sz="1250">
-                <a:solidFill>
-                  <a:srgbClr val="333333"/>
-                </a:solidFill>
-                <a:latin typeface="Calibri"/>
-              </a:rPr>
-              <a:t>• </a:t>
-            </a:r>
-            <a:r>
-              <a:rPr sz="1250">
-                <a:solidFill>
-                  <a:srgbClr val="333333"/>
-                </a:solidFill>
-                <a:latin typeface="Calibri"/>
-              </a:rPr>
-              <a:t>Strongest evidence yet for a hardware fix (stiffen/damp the flexure) over continued controller tuning.</a:t>
-            </a:r>
-          </a:p>
-        </p:txBody>
-      </p:sp>
-      <p:pic>
-        <p:nvPicPr>
-          <p:cNvPr id="5" name="Picture 4" descr="fta_open_loop_bode_summary.png"/>
-          <p:cNvPicPr>
-            <a:picLocks noChangeAspect="1"/>
-          </p:cNvPicPr>
-          <p:nvPr/>
-        </p:nvPicPr>
-        <p:blipFill>
-          <a:blip r:embed="rId3"/>
-          <a:stretch>
-            <a:fillRect/>
-          </a:stretch>
-        </p:blipFill>
-        <p:spPr>
-          <a:xfrm>
-            <a:off x="7031760" y="1143000"/>
-            <a:ext cx="4041240" cy="3565800"/>
-          </a:xfrm>
-          <a:prstGeom prst="rect">
-            <a:avLst/>
-          </a:prstGeom>
-        </p:spPr>
-      </p:pic>
-    </p:spTree>
-  </p:cSld>
-  <p:clrMapOvr>
-    <a:masterClrMapping/>
-  </p:clrMapOvr>
-</p:sld>
-</file>
-
-<file path=ppt/slides/slide21.xml><?xml version="1.0" encoding="utf-8"?>
 <p:sld xmlns:a="http://schemas.openxmlformats.org/drawingml/2006/main" xmlns:p="http://schemas.openxmlformats.org/presentationml/2006/main" xmlns:r="http://schemas.openxmlformats.org/officeDocument/2006/relationships" xmlns:p14="http://schemas.microsoft.com/office/powerpoint/2010/main" xmlns:p15="http://schemas.microsoft.com/office/powerpoint/2012/main" xmlns:mc="http://schemas.openxmlformats.org/markup-compatibility/2006">
   <p:cSld>
     <p:spTree>
@@ -5280,6 +5282,368 @@
       <p:transition spd="slow"/>
     </mc:Fallback>
   </mc:AlternateContent>
+</p:sld>
+</file>
+
+<file path=ppt/slides/slide21.xml><?xml version="1.0" encoding="utf-8"?>
+<p:sld xmlns:a="http://schemas.openxmlformats.org/drawingml/2006/main" xmlns:p="http://schemas.openxmlformats.org/presentationml/2006/main" xmlns:r="http://schemas.openxmlformats.org/officeDocument/2006/relationships">
+  <p:cSld>
+    <p:spTree>
+      <p:nvGrpSpPr>
+        <p:cNvPr id="1" name=""/>
+        <p:cNvGrpSpPr/>
+        <p:nvPr/>
+      </p:nvGrpSpPr>
+      <p:grpSpPr/>
+      <p:sp>
+        <p:nvSpPr>
+          <p:cNvPr id="2" name="TextBox 1"/>
+          <p:cNvSpPr txBox="1"/>
+          <p:nvPr/>
+        </p:nvSpPr>
+        <p:spPr>
+          <a:xfrm>
+            <a:off x="457200" y="228600"/>
+            <a:ext cx="11246760" cy="486360"/>
+          </a:xfrm>
+          <a:prstGeom prst="rect">
+            <a:avLst/>
+          </a:prstGeom>
+          <a:noFill/>
+        </p:spPr>
+        <p:txBody>
+          <a:bodyPr wrap="square">
+            <a:spAutoFit/>
+          </a:bodyPr>
+          <a:lstStyle/>
+          <a:p>
+            <a:r>
+              <a:rPr sz="2400" b="1">
+                <a:solidFill>
+                  <a:srgbClr val="1A1A2E"/>
+                </a:solidFill>
+                <a:latin typeface="Calibri"/>
+              </a:rPr>
+              <a:t>New ring-down measurements, both axes — the resonance behind the updated FEA comparison</a:t>
+            </a:r>
+          </a:p>
+        </p:txBody>
+      </p:sp>
+      <p:cxnSp>
+        <p:nvCxnSpPr>
+          <p:cNvPr id="3" name="Connector 2"/>
+          <p:cNvCxnSpPr/>
+          <p:nvPr/>
+        </p:nvCxnSpPr>
+        <p:spPr>
+          <a:xfrm>
+            <a:off x="457200" y="960120"/>
+            <a:ext cx="11247120" cy="0"/>
+          </a:xfrm>
+          <a:prstGeom prst="line">
+            <a:avLst/>
+          </a:prstGeom>
+          <a:ln w="19080">
+            <a:solidFill>
+              <a:srgbClr val="2E5C8A"/>
+            </a:solidFill>
+          </a:ln>
+        </p:spPr>
+        <p:style>
+          <a:lnRef idx="2">
+            <a:schemeClr val="accent1"/>
+          </a:lnRef>
+          <a:fillRef idx="0">
+            <a:schemeClr val="accent1"/>
+          </a:fillRef>
+          <a:effectRef idx="1">
+            <a:schemeClr val="accent1"/>
+          </a:effectRef>
+          <a:fontRef idx="minor">
+            <a:schemeClr val="tx1"/>
+          </a:fontRef>
+        </p:style>
+      </p:cxnSp>
+      <p:sp>
+        <p:nvSpPr>
+          <p:cNvPr id="4" name="TextBox 3"/>
+          <p:cNvSpPr txBox="1"/>
+          <p:nvPr/>
+        </p:nvSpPr>
+        <p:spPr>
+          <a:xfrm>
+            <a:off x="457200" y="1080000"/>
+            <a:ext cx="11246760" cy="500000"/>
+          </a:xfrm>
+          <a:prstGeom prst="rect">
+            <a:avLst/>
+          </a:prstGeom>
+          <a:noFill/>
+        </p:spPr>
+        <p:txBody>
+          <a:bodyPr wrap="square">
+            <a:spAutoFit/>
+          </a:bodyPr>
+          <a:lstStyle/>
+          <a:p>
+            <a:r>
+              <a:rPr sz="1250">
+                <a:solidFill>
+                  <a:srgbClr val="333333"/>
+                </a:solidFill>
+                <a:latin typeface="Calibri"/>
+              </a:rPr>
+              <a:t>Model-free peak-spacing estimate (dashed curve_fit overlay is unreliable — see annotation on each plot); tick-timestamped, same method as the original 38.5Hz measurement.</a:t>
+            </a:r>
+          </a:p>
+        </p:txBody>
+      </p:sp>
+      <p:pic>
+        <p:nvPicPr>
+          <p:cNvPr id="5" name="Picture 4" descr="fta_ringdown_xaxis_20260828T003210Z.png"/>
+          <p:cNvPicPr>
+            <a:picLocks noChangeAspect="1"/>
+          </p:cNvPicPr>
+          <p:nvPr/>
+        </p:nvPicPr>
+        <p:blipFill>
+          <a:blip r:embed="rId2"/>
+          <a:stretch>
+            <a:fillRect/>
+          </a:stretch>
+        </p:blipFill>
+        <p:spPr>
+          <a:xfrm>
+            <a:off x="457200" y="1650000"/>
+            <a:ext cx="3595587" cy="1618000"/>
+          </a:xfrm>
+          <a:prstGeom prst="rect">
+            <a:avLst/>
+          </a:prstGeom>
+        </p:spPr>
+      </p:pic>
+      <p:pic>
+        <p:nvPicPr>
+          <p:cNvPr id="6" name="Picture 5" descr="fta_ringdown_xaxis_20260828T003754Z.png"/>
+          <p:cNvPicPr>
+            <a:picLocks noChangeAspect="1"/>
+          </p:cNvPicPr>
+          <p:nvPr/>
+        </p:nvPicPr>
+        <p:blipFill>
+          <a:blip r:embed="rId3"/>
+          <a:stretch>
+            <a:fillRect/>
+          </a:stretch>
+        </p:blipFill>
+        <p:spPr>
+          <a:xfrm>
+            <a:off x="4282787" y="1650000"/>
+            <a:ext cx="3595587" cy="1618000"/>
+          </a:xfrm>
+          <a:prstGeom prst="rect">
+            <a:avLst/>
+          </a:prstGeom>
+        </p:spPr>
+      </p:pic>
+      <p:pic>
+        <p:nvPicPr>
+          <p:cNvPr id="7" name="Picture 6" descr="fta_ringdown_yaxis_20260828T003403Z_fixed.png"/>
+          <p:cNvPicPr>
+            <a:picLocks noChangeAspect="1"/>
+          </p:cNvPicPr>
+          <p:nvPr/>
+        </p:nvPicPr>
+        <p:blipFill>
+          <a:blip r:embed="rId4"/>
+          <a:stretch>
+            <a:fillRect/>
+          </a:stretch>
+        </p:blipFill>
+        <p:spPr>
+          <a:xfrm>
+            <a:off x="8108374" y="1650000"/>
+            <a:ext cx="3595587" cy="1618000"/>
+          </a:xfrm>
+          <a:prstGeom prst="rect">
+            <a:avLst/>
+          </a:prstGeom>
+        </p:spPr>
+      </p:pic>
+      <p:sp>
+        <p:nvSpPr>
+          <p:cNvPr id="8" name="Caption 1"/>
+          <p:cNvSpPr txBox="1"/>
+          <p:nvPr/>
+        </p:nvSpPr>
+        <p:spPr>
+          <a:xfrm>
+            <a:off x="457200" y="3330000"/>
+            <a:ext cx="3595587" cy="700000"/>
+          </a:xfrm>
+          <a:prstGeom prst="rect">
+            <a:avLst/>
+          </a:prstGeom>
+          <a:noFill/>
+        </p:spPr>
+        <p:txBody>
+          <a:bodyPr wrap="square">
+            <a:spAutoFit/>
+          </a:bodyPr>
+          <a:lstStyle/>
+          <a:p>
+            <a:r>
+              <a:rPr sz="1150" b="1">
+                <a:solidFill>
+                  <a:srgbClr val="333333"/>
+                </a:solidFill>
+                <a:latin typeface="Calibri"/>
+              </a:rPr>
+              <a:t>X-axis, trial 1: 47.3Hz</a:t>
+            </a:r>
+          </a:p>
+          <a:p>
+            <a:r>
+              <a:rPr sz="1050">
+                <a:solidFill>
+                  <a:srgbClr val="666666"/>
+                </a:solidFill>
+                <a:latin typeface="Calibri"/>
+              </a:rPr>
+              <a:t>dac_y→cx, primary axis</a:t>
+            </a:r>
+          </a:p>
+        </p:txBody>
+      </p:sp>
+      <p:sp>
+        <p:nvSpPr>
+          <p:cNvPr id="9" name="Caption 2"/>
+          <p:cNvSpPr txBox="1"/>
+          <p:nvPr/>
+        </p:nvSpPr>
+        <p:spPr>
+          <a:xfrm>
+            <a:off x="4282787" y="3330000"/>
+            <a:ext cx="3595587" cy="700000"/>
+          </a:xfrm>
+          <a:prstGeom prst="rect">
+            <a:avLst/>
+          </a:prstGeom>
+          <a:noFill/>
+        </p:spPr>
+        <p:txBody>
+          <a:bodyPr wrap="square">
+            <a:spAutoFit/>
+          </a:bodyPr>
+          <a:lstStyle/>
+          <a:p>
+            <a:r>
+              <a:rPr sz="1150" b="1">
+                <a:solidFill>
+                  <a:srgbClr val="333333"/>
+                </a:solidFill>
+                <a:latin typeface="Calibri"/>
+              </a:rPr>
+              <a:t>X-axis, trial 2 (immediate repeat): 47.0Hz</a:t>
+            </a:r>
+          </a:p>
+          <a:p>
+            <a:r>
+              <a:rPr sz="1050">
+                <a:solidFill>
+                  <a:srgbClr val="666666"/>
+                </a:solidFill>
+                <a:latin typeface="Calibri"/>
+              </a:rPr>
+              <a:t>dac_y→cx — tight agreement with trial 1</a:t>
+            </a:r>
+          </a:p>
+        </p:txBody>
+      </p:sp>
+      <p:sp>
+        <p:nvSpPr>
+          <p:cNvPr id="10" name="Caption 3"/>
+          <p:cNvSpPr txBox="1"/>
+          <p:nvPr/>
+        </p:nvSpPr>
+        <p:spPr>
+          <a:xfrm>
+            <a:off x="8108374" y="3330000"/>
+            <a:ext cx="3595587" cy="700000"/>
+          </a:xfrm>
+          <a:prstGeom prst="rect">
+            <a:avLst/>
+          </a:prstGeom>
+          <a:noFill/>
+        </p:spPr>
+        <p:txBody>
+          <a:bodyPr wrap="square">
+            <a:spAutoFit/>
+          </a:bodyPr>
+          <a:lstStyle/>
+          <a:p>
+            <a:r>
+              <a:rPr sz="1150" b="1">
+                <a:solidFill>
+                  <a:srgbClr val="333333"/>
+                </a:solidFill>
+                <a:latin typeface="Calibri"/>
+              </a:rPr>
+              <a:t>Y-axis, first-ever trial: 50.1Hz</a:t>
+            </a:r>
+          </a:p>
+          <a:p>
+            <a:r>
+              <a:rPr sz="1050">
+                <a:solidFill>
+                  <a:srgbClr val="666666"/>
+                </a:solidFill>
+                <a:latin typeface="Calibri"/>
+              </a:rPr>
+              <a:t>dac_x→cy — only one trial so far</a:t>
+            </a:r>
+          </a:p>
+        </p:txBody>
+      </p:sp>
+      <p:sp>
+        <p:nvSpPr>
+          <p:cNvPr id="11" name="Note"/>
+          <p:cNvSpPr txBox="1"/>
+          <p:nvPr/>
+        </p:nvSpPr>
+        <p:spPr>
+          <a:xfrm>
+            <a:off x="457200" y="4200000"/>
+            <a:ext cx="11246760" cy="700000"/>
+          </a:xfrm>
+          <a:prstGeom prst="rect">
+            <a:avLst/>
+          </a:prstGeom>
+          <a:noFill/>
+        </p:spPr>
+        <p:txBody>
+          <a:bodyPr wrap="square">
+            <a:spAutoFit/>
+          </a:bodyPr>
+          <a:lstStyle/>
+          <a:p>
+            <a:r>
+              <a:rPr sz="1150" i="1">
+                <a:solidFill>
+                  <a:srgbClr val="555555"/>
+                </a:solidFill>
+                <a:latin typeface="Calibri"/>
+              </a:rPr>
+              <a:t>Both axes land close to each other and notably not close to the previously-documented 38.5Hz. Same trustworthy tick-timestamped peak-spacing method as the original measurement, so this reads as a real, reproducible shift in the physical resonance since then — see next slide for the updated FEA comparison.</a:t>
+            </a:r>
+          </a:p>
+        </p:txBody>
+      </p:sp>
+    </p:spTree>
+  </p:cSld>
+  <p:clrMapOvr>
+    <a:masterClrMapping/>
+  </p:clrMapOvr>
 </p:sld>
 </file>
 
@@ -6239,7 +6603,7 @@
         <p:spPr>
           <a:xfrm>
             <a:off x="457200" y="228600"/>
-            <a:ext cx="11246760" cy="486360"/>
+            <a:ext cx="11246760" cy="640000"/>
           </a:xfrm>
           <a:prstGeom prst="rect">
             <a:avLst/>
@@ -6259,7 +6623,7 @@
                 </a:solidFill>
                 <a:latin typeface="Calibri"/>
               </a:rPr>
-              <a:t>New ring-down measurements, both axes — the resonance behind the updated FEA comparison</a:t>
+              <a:t>I2C link + PID completion: essentially lossless end to end</a:t>
             </a:r>
           </a:p>
         </p:txBody>
@@ -6307,8 +6671,8 @@
         </p:nvSpPr>
         <p:spPr>
           <a:xfrm>
-            <a:off x="457200" y="1080000"/>
-            <a:ext cx="11246760" cy="500000"/>
+            <a:off x="457200" y="1180000"/>
+            <a:ext cx="5450000" cy="4400000"/>
           </a:xfrm>
           <a:prstGeom prst="rect">
             <a:avLst/>
@@ -6321,6 +6685,11 @@
           </a:bodyPr>
           <a:lstStyle/>
           <a:p>
+            <a:pPr>
+              <a:spcAft>
+                <a:spcPts val="900"/>
+              </a:spcAft>
+            </a:pPr>
             <a:r>
               <a:rPr sz="1250">
                 <a:solidFill>
@@ -6328,14 +6697,790 @@
                 </a:solidFill>
                 <a:latin typeface="Calibri"/>
               </a:rPr>
-              <a:t>Model-free peak-spacing estimate (dashed curve_fit overlay is unreliable — see annotation on each plot); tick-timestamped, same method as the original 38.5Hz measurement.</a:t>
+              <a:t>• </a:t>
+            </a:r>
+            <a:r>
+              <a:rPr sz="1250">
+                <a:solidFill>
+                  <a:srgbClr val="333333"/>
+                </a:solidFill>
+                <a:latin typeface="Calibri"/>
+              </a:rPr>
+              <a:t>Link completeness (Pi send → Nucleo I2C reception): the Pi's own capture-enumerated seq counter (increments once per camera frame, before detection/send outcome is known) unwrapped and compared against the Nucleo's ISR-level pkts+errs counters — real ground truth on both ends, immune to the separately-known ~4-8% VCP relay line loss (that only affects host-side observability, not the real link).</a:t>
+            </a:r>
+          </a:p>
+          <a:p>
+            <a:pPr>
+              <a:spcAft>
+                <a:spcPts val="900"/>
+              </a:spcAft>
+            </a:pPr>
+            <a:r>
+              <a:rPr sz="1250">
+                <a:solidFill>
+                  <a:srgbClr val="333333"/>
+                </a:solidFill>
+                <a:latin typeface="Calibri"/>
+              </a:rPr>
+              <a:t>• </a:t>
+            </a:r>
+            <a:r>
+              <a:rPr sz="1250">
+                <a:solidFill>
+                  <a:srgbClr val="333333"/>
+                </a:solidFill>
+                <a:latin typeface="Calibri"/>
+              </a:rPr>
+              <a:t>Confident packet → completed PID loop: measured via two new firmware counters (confident_pkts=, cseq=). 99.97% (6423/6425) across 3 trials — the single-slot g_latest_beam "mailbox" can in principle drop a packet if two I2C receptions land in the same critical section; measured rate is ~1 in 3200, not a meaningful limiter.</a:t>
+            </a:r>
+          </a:p>
+          <a:p>
+            <a:pPr>
+              <a:spcAft>
+                <a:spcPts val="900"/>
+              </a:spcAft>
+            </a:pPr>
+            <a:r>
+              <a:rPr sz="1250">
+                <a:solidFill>
+                  <a:srgbClr val="333333"/>
+                </a:solidFill>
+                <a:latin typeface="Calibri"/>
+              </a:rPr>
+              <a:t>• </a:t>
+            </a:r>
+            <a:r>
+              <a:rPr sz="1250">
+                <a:solidFill>
+                  <a:srgbClr val="333333"/>
+                </a:solidFill>
+                <a:latin typeface="Calibri"/>
+              </a:rPr>
+              <a:t>Not measured: whether the camera driver itself (Picamera2/libcamera) drops frames before Python's capture_array() call returns them — a different, deeper layer than anything checked here.</a:t>
+            </a:r>
+          </a:p>
+        </p:txBody>
+      </p:sp>
+      <p:graphicFrame>
+        <p:nvGraphicFramePr>
+          <p:cNvPr id="5" name="Table 4"/>
+          <p:cNvGraphicFramePr>
+            <a:graphicFrameLocks noGrp="1"/>
+          </p:cNvGraphicFramePr>
+          <p:nvPr/>
+        </p:nvGraphicFramePr>
+        <p:xfrm>
+          <a:off x="6350000" y="1550000"/>
+          <a:ext cx="5250000" cy="2200000"/>
+        </p:xfrm>
+        <a:graphic>
+          <a:graphicData uri="http://schemas.openxmlformats.org/drawingml/2006/table">
+            <a:tbl>
+              <a:tblPr firstRow="1" bandRow="1">
+                <a:tableStyleId>{5C22544A-7EE6-4342-B048-85BDC9FD1C3A}</a:tableStyleId>
+              </a:tblPr>
+              <a:tblGrid>
+                <a:gridCol w="1100000"/>
+                <a:gridCol w="1500000"/>
+                <a:gridCol w="1900000"/>
+                <a:gridCol w="750000"/>
+              </a:tblGrid>
+              <a:tr h="440000">
+                <a:tc>
+                  <a:txBody>
+                    <a:bodyPr/>
+                    <a:lstStyle/>
+                    <a:p>
+                      <a:pPr algn="ctr"/>
+                      <a:r>
+                        <a:rPr sz="1250" b="1">
+                          <a:solidFill>
+                            <a:srgbClr val="FFFFFF"/>
+                          </a:solidFill>
+                          <a:latin typeface="Calibri"/>
+                        </a:rPr>
+                        <a:t>Trial</a:t>
+                      </a:r>
+                    </a:p>
+                  </a:txBody>
+                  <a:tcPr anchor="ctr">
+                    <a:solidFill>
+                      <a:srgbClr val="2E5C8A"/>
+                    </a:solidFill>
+                  </a:tcPr>
+                </a:tc>
+                <a:tc>
+                  <a:txBody>
+                    <a:bodyPr/>
+                    <a:lstStyle/>
+                    <a:p>
+                      <a:pPr algn="ctr"/>
+                      <a:r>
+                        <a:rPr sz="1250" b="1">
+                          <a:solidFill>
+                            <a:srgbClr val="FFFFFF"/>
+                          </a:solidFill>
+                          <a:latin typeface="Calibri"/>
+                        </a:rPr>
+                        <a:t>Pi sends (seq)</a:t>
+                      </a:r>
+                    </a:p>
+                  </a:txBody>
+                  <a:tcPr anchor="ctr">
+                    <a:solidFill>
+                      <a:srgbClr val="2E5C8A"/>
+                    </a:solidFill>
+                  </a:tcPr>
+                </a:tc>
+                <a:tc>
+                  <a:txBody>
+                    <a:bodyPr/>
+                    <a:lstStyle/>
+                    <a:p>
+                      <a:pPr algn="ctr"/>
+                      <a:r>
+                        <a:rPr sz="1250" b="1">
+                          <a:solidFill>
+                            <a:srgbClr val="FFFFFF"/>
+                          </a:solidFill>
+                          <a:latin typeface="Calibri"/>
+                        </a:rPr>
+                        <a:t>Nucleo registered</a:t>
+                      </a:r>
+                    </a:p>
+                  </a:txBody>
+                  <a:tcPr anchor="ctr">
+                    <a:solidFill>
+                      <a:srgbClr val="2E5C8A"/>
+                    </a:solidFill>
+                  </a:tcPr>
+                </a:tc>
+                <a:tc>
+                  <a:txBody>
+                    <a:bodyPr/>
+                    <a:lstStyle/>
+                    <a:p>
+                      <a:pPr algn="ctr"/>
+                      <a:r>
+                        <a:rPr sz="1250" b="1">
+                          <a:solidFill>
+                            <a:srgbClr val="FFFFFF"/>
+                          </a:solidFill>
+                          <a:latin typeface="Calibri"/>
+                        </a:rPr>
+                        <a:t>Lost</a:t>
+                      </a:r>
+                    </a:p>
+                  </a:txBody>
+                  <a:tcPr anchor="ctr">
+                    <a:solidFill>
+                      <a:srgbClr val="2E5C8A"/>
+                    </a:solidFill>
+                  </a:tcPr>
+                </a:tc>
+              </a:tr>
+              <a:tr h="440000">
+                <a:tc>
+                  <a:txBody>
+                    <a:bodyPr/>
+                    <a:lstStyle/>
+                    <a:p>
+                      <a:pPr algn="ctr"/>
+                      <a:r>
+                        <a:rPr sz="1250">
+                          <a:solidFill>
+                            <a:srgbClr val="333333"/>
+                          </a:solidFill>
+                          <a:latin typeface="Calibri"/>
+                        </a:rPr>
+                        <a:t>1</a:t>
+                      </a:r>
+                    </a:p>
+                  </a:txBody>
+                  <a:tcPr anchor="ctr">
+                    <a:solidFill>
+                      <a:srgbClr val="FFFFFF"/>
+                    </a:solidFill>
+                  </a:tcPr>
+                </a:tc>
+                <a:tc>
+                  <a:txBody>
+                    <a:bodyPr/>
+                    <a:lstStyle/>
+                    <a:p>
+                      <a:pPr algn="ctr"/>
+                      <a:r>
+                        <a:rPr sz="1250">
+                          <a:solidFill>
+                            <a:srgbClr val="333333"/>
+                          </a:solidFill>
+                          <a:latin typeface="Calibri"/>
+                        </a:rPr>
+                        <a:t>3610</a:t>
+                      </a:r>
+                    </a:p>
+                  </a:txBody>
+                  <a:tcPr anchor="ctr">
+                    <a:solidFill>
+                      <a:srgbClr val="FFFFFF"/>
+                    </a:solidFill>
+                  </a:tcPr>
+                </a:tc>
+                <a:tc>
+                  <a:txBody>
+                    <a:bodyPr/>
+                    <a:lstStyle/>
+                    <a:p>
+                      <a:pPr algn="ctr"/>
+                      <a:r>
+                        <a:rPr sz="1250">
+                          <a:solidFill>
+                            <a:srgbClr val="333333"/>
+                          </a:solidFill>
+                          <a:latin typeface="Calibri"/>
+                        </a:rPr>
+                        <a:t>3610</a:t>
+                      </a:r>
+                    </a:p>
+                  </a:txBody>
+                  <a:tcPr anchor="ctr">
+                    <a:solidFill>
+                      <a:srgbClr val="FFFFFF"/>
+                    </a:solidFill>
+                  </a:tcPr>
+                </a:tc>
+                <a:tc>
+                  <a:txBody>
+                    <a:bodyPr/>
+                    <a:lstStyle/>
+                    <a:p>
+                      <a:pPr algn="ctr"/>
+                      <a:r>
+                        <a:rPr sz="1250">
+                          <a:solidFill>
+                            <a:srgbClr val="333333"/>
+                          </a:solidFill>
+                          <a:latin typeface="Calibri"/>
+                        </a:rPr>
+                        <a:t>0</a:t>
+                      </a:r>
+                    </a:p>
+                  </a:txBody>
+                  <a:tcPr anchor="ctr">
+                    <a:solidFill>
+                      <a:srgbClr val="FFFFFF"/>
+                    </a:solidFill>
+                  </a:tcPr>
+                </a:tc>
+              </a:tr>
+              <a:tr h="440000">
+                <a:tc>
+                  <a:txBody>
+                    <a:bodyPr/>
+                    <a:lstStyle/>
+                    <a:p>
+                      <a:pPr algn="ctr"/>
+                      <a:r>
+                        <a:rPr sz="1250">
+                          <a:solidFill>
+                            <a:srgbClr val="333333"/>
+                          </a:solidFill>
+                          <a:latin typeface="Calibri"/>
+                        </a:rPr>
+                        <a:t>2</a:t>
+                      </a:r>
+                    </a:p>
+                  </a:txBody>
+                  <a:tcPr anchor="ctr">
+                    <a:solidFill>
+                      <a:srgbClr val="F2F4F7"/>
+                    </a:solidFill>
+                  </a:tcPr>
+                </a:tc>
+                <a:tc>
+                  <a:txBody>
+                    <a:bodyPr/>
+                    <a:lstStyle/>
+                    <a:p>
+                      <a:pPr algn="ctr"/>
+                      <a:r>
+                        <a:rPr sz="1250">
+                          <a:solidFill>
+                            <a:srgbClr val="333333"/>
+                          </a:solidFill>
+                          <a:latin typeface="Calibri"/>
+                        </a:rPr>
+                        <a:t>3672</a:t>
+                      </a:r>
+                    </a:p>
+                  </a:txBody>
+                  <a:tcPr anchor="ctr">
+                    <a:solidFill>
+                      <a:srgbClr val="F2F4F7"/>
+                    </a:solidFill>
+                  </a:tcPr>
+                </a:tc>
+                <a:tc>
+                  <a:txBody>
+                    <a:bodyPr/>
+                    <a:lstStyle/>
+                    <a:p>
+                      <a:pPr algn="ctr"/>
+                      <a:r>
+                        <a:rPr sz="1250">
+                          <a:solidFill>
+                            <a:srgbClr val="333333"/>
+                          </a:solidFill>
+                          <a:latin typeface="Calibri"/>
+                        </a:rPr>
+                        <a:t>3672</a:t>
+                      </a:r>
+                    </a:p>
+                  </a:txBody>
+                  <a:tcPr anchor="ctr">
+                    <a:solidFill>
+                      <a:srgbClr val="F2F4F7"/>
+                    </a:solidFill>
+                  </a:tcPr>
+                </a:tc>
+                <a:tc>
+                  <a:txBody>
+                    <a:bodyPr/>
+                    <a:lstStyle/>
+                    <a:p>
+                      <a:pPr algn="ctr"/>
+                      <a:r>
+                        <a:rPr sz="1250">
+                          <a:solidFill>
+                            <a:srgbClr val="333333"/>
+                          </a:solidFill>
+                          <a:latin typeface="Calibri"/>
+                        </a:rPr>
+                        <a:t>0</a:t>
+                      </a:r>
+                    </a:p>
+                  </a:txBody>
+                  <a:tcPr anchor="ctr">
+                    <a:solidFill>
+                      <a:srgbClr val="F2F4F7"/>
+                    </a:solidFill>
+                  </a:tcPr>
+                </a:tc>
+              </a:tr>
+              <a:tr h="440000">
+                <a:tc>
+                  <a:txBody>
+                    <a:bodyPr/>
+                    <a:lstStyle/>
+                    <a:p>
+                      <a:pPr algn="ctr"/>
+                      <a:r>
+                        <a:rPr sz="1250">
+                          <a:solidFill>
+                            <a:srgbClr val="333333"/>
+                          </a:solidFill>
+                          <a:latin typeface="Calibri"/>
+                        </a:rPr>
+                        <a:t>3</a:t>
+                      </a:r>
+                    </a:p>
+                  </a:txBody>
+                  <a:tcPr anchor="ctr">
+                    <a:solidFill>
+                      <a:srgbClr val="FFFFFF"/>
+                    </a:solidFill>
+                  </a:tcPr>
+                </a:tc>
+                <a:tc>
+                  <a:txBody>
+                    <a:bodyPr/>
+                    <a:lstStyle/>
+                    <a:p>
+                      <a:pPr algn="ctr"/>
+                      <a:r>
+                        <a:rPr sz="1250">
+                          <a:solidFill>
+                            <a:srgbClr val="333333"/>
+                          </a:solidFill>
+                          <a:latin typeface="Calibri"/>
+                        </a:rPr>
+                        <a:t>3591</a:t>
+                      </a:r>
+                    </a:p>
+                  </a:txBody>
+                  <a:tcPr anchor="ctr">
+                    <a:solidFill>
+                      <a:srgbClr val="FFFFFF"/>
+                    </a:solidFill>
+                  </a:tcPr>
+                </a:tc>
+                <a:tc>
+                  <a:txBody>
+                    <a:bodyPr/>
+                    <a:lstStyle/>
+                    <a:p>
+                      <a:pPr algn="ctr"/>
+                      <a:r>
+                        <a:rPr sz="1250">
+                          <a:solidFill>
+                            <a:srgbClr val="333333"/>
+                          </a:solidFill>
+                          <a:latin typeface="Calibri"/>
+                        </a:rPr>
+                        <a:t>3591</a:t>
+                      </a:r>
+                    </a:p>
+                  </a:txBody>
+                  <a:tcPr anchor="ctr">
+                    <a:solidFill>
+                      <a:srgbClr val="FFFFFF"/>
+                    </a:solidFill>
+                  </a:tcPr>
+                </a:tc>
+                <a:tc>
+                  <a:txBody>
+                    <a:bodyPr/>
+                    <a:lstStyle/>
+                    <a:p>
+                      <a:pPr algn="ctr"/>
+                      <a:r>
+                        <a:rPr sz="1250">
+                          <a:solidFill>
+                            <a:srgbClr val="333333"/>
+                          </a:solidFill>
+                          <a:latin typeface="Calibri"/>
+                        </a:rPr>
+                        <a:t>0</a:t>
+                      </a:r>
+                    </a:p>
+                  </a:txBody>
+                  <a:tcPr anchor="ctr">
+                    <a:solidFill>
+                      <a:srgbClr val="FFFFFF"/>
+                    </a:solidFill>
+                  </a:tcPr>
+                </a:tc>
+              </a:tr>
+              <a:tr h="440000">
+                <a:tc>
+                  <a:txBody>
+                    <a:bodyPr/>
+                    <a:lstStyle/>
+                    <a:p>
+                      <a:pPr algn="ctr"/>
+                      <a:r>
+                        <a:rPr sz="1250">
+                          <a:solidFill>
+                            <a:srgbClr val="333333"/>
+                          </a:solidFill>
+                          <a:latin typeface="Calibri"/>
+                        </a:rPr>
+                        <a:t>Total</a:t>
+                      </a:r>
+                    </a:p>
+                  </a:txBody>
+                  <a:tcPr anchor="ctr">
+                    <a:solidFill>
+                      <a:srgbClr val="F2F4F7"/>
+                    </a:solidFill>
+                  </a:tcPr>
+                </a:tc>
+                <a:tc>
+                  <a:txBody>
+                    <a:bodyPr/>
+                    <a:lstStyle/>
+                    <a:p>
+                      <a:pPr algn="ctr"/>
+                      <a:r>
+                        <a:rPr sz="1250">
+                          <a:solidFill>
+                            <a:srgbClr val="333333"/>
+                          </a:solidFill>
+                          <a:latin typeface="Calibri"/>
+                        </a:rPr>
+                        <a:t>10873</a:t>
+                      </a:r>
+                    </a:p>
+                  </a:txBody>
+                  <a:tcPr anchor="ctr">
+                    <a:solidFill>
+                      <a:srgbClr val="F2F4F7"/>
+                    </a:solidFill>
+                  </a:tcPr>
+                </a:tc>
+                <a:tc>
+                  <a:txBody>
+                    <a:bodyPr/>
+                    <a:lstStyle/>
+                    <a:p>
+                      <a:pPr algn="ctr"/>
+                      <a:r>
+                        <a:rPr sz="1250">
+                          <a:solidFill>
+                            <a:srgbClr val="333333"/>
+                          </a:solidFill>
+                          <a:latin typeface="Calibri"/>
+                        </a:rPr>
+                        <a:t>10873</a:t>
+                      </a:r>
+                    </a:p>
+                  </a:txBody>
+                  <a:tcPr anchor="ctr">
+                    <a:solidFill>
+                      <a:srgbClr val="F2F4F7"/>
+                    </a:solidFill>
+                  </a:tcPr>
+                </a:tc>
+                <a:tc>
+                  <a:txBody>
+                    <a:bodyPr/>
+                    <a:lstStyle/>
+                    <a:p>
+                      <a:pPr algn="ctr"/>
+                      <a:r>
+                        <a:rPr sz="1250">
+                          <a:solidFill>
+                            <a:srgbClr val="333333"/>
+                          </a:solidFill>
+                          <a:latin typeface="Calibri"/>
+                        </a:rPr>
+                        <a:t>0</a:t>
+                      </a:r>
+                    </a:p>
+                  </a:txBody>
+                  <a:tcPr anchor="ctr">
+                    <a:solidFill>
+                      <a:srgbClr val="F2F4F7"/>
+                    </a:solidFill>
+                  </a:tcPr>
+                </a:tc>
+              </a:tr>
+            </a:tbl>
+          </a:graphicData>
+        </a:graphic>
+      </p:graphicFrame>
+      <p:sp>
+        <p:nvSpPr>
+          <p:cNvPr id="6" name="TextBox 5"/>
+          <p:cNvSpPr txBox="1"/>
+          <p:nvPr/>
+        </p:nvSpPr>
+        <p:spPr>
+          <a:xfrm>
+            <a:off x="6350000" y="3850000"/>
+            <a:ext cx="5250000" cy="600000"/>
+          </a:xfrm>
+          <a:prstGeom prst="rect">
+            <a:avLst/>
+          </a:prstGeom>
+          <a:noFill/>
+        </p:spPr>
+        <p:txBody>
+          <a:bodyPr wrap="square">
+            <a:spAutoFit/>
+          </a:bodyPr>
+          <a:lstStyle/>
+          <a:p>
+            <a:r>
+              <a:rPr sz="1050" i="1">
+                <a:solidFill>
+                  <a:srgbClr val="898781"/>
+                </a:solidFill>
+                <a:latin typeface="Calibri"/>
+              </a:rPr>
+              <a:t>0 lost across all 3 trials, ~10,873 real sends -- 8s windows, open_loop/amp off, link-only check</a:t>
+            </a:r>
+          </a:p>
+        </p:txBody>
+      </p:sp>
+    </p:spTree>
+  </p:cSld>
+  <p:clrMapOvr>
+    <a:masterClrMapping/>
+  </p:clrMapOvr>
+</p:sld>
+</file>
+
+<file path=ppt/slides/slide25.xml><?xml version="1.0" encoding="utf-8"?>
+<p:sld xmlns:a="http://schemas.openxmlformats.org/drawingml/2006/main" xmlns:p="http://schemas.openxmlformats.org/presentationml/2006/main" xmlns:r="http://schemas.openxmlformats.org/officeDocument/2006/relationships">
+  <p:cSld>
+    <p:spTree>
+      <p:nvGrpSpPr>
+        <p:cNvPr id="1" name=""/>
+        <p:cNvGrpSpPr/>
+        <p:nvPr/>
+      </p:nvGrpSpPr>
+      <p:grpSpPr/>
+      <p:sp>
+        <p:nvSpPr>
+          <p:cNvPr id="2" name="TextBox 1"/>
+          <p:cNvSpPr txBox="1"/>
+          <p:nvPr/>
+        </p:nvSpPr>
+        <p:spPr>
+          <a:xfrm>
+            <a:off x="457200" y="228600"/>
+            <a:ext cx="11246760" cy="640000"/>
+          </a:xfrm>
+          <a:prstGeom prst="rect">
+            <a:avLst/>
+          </a:prstGeom>
+          <a:noFill/>
+        </p:spPr>
+        <p:txBody>
+          <a:bodyPr wrap="square">
+            <a:spAutoFit/>
+          </a:bodyPr>
+          <a:lstStyle/>
+          <a:p>
+            <a:r>
+              <a:rPr sz="2400" b="1">
+                <a:solidFill>
+                  <a:srgbClr val="1A1A2E"/>
+                </a:solidFill>
+                <a:latin typeface="Calibri"/>
+              </a:rPr>
+              <a:t>Real control-step timing jitter (current config)</a:t>
+            </a:r>
+          </a:p>
+        </p:txBody>
+      </p:sp>
+      <p:cxnSp>
+        <p:nvCxnSpPr>
+          <p:cNvPr id="3" name="Connector 2"/>
+          <p:cNvCxnSpPr/>
+          <p:nvPr/>
+        </p:nvCxnSpPr>
+        <p:spPr>
+          <a:xfrm>
+            <a:off x="457200" y="960120"/>
+            <a:ext cx="11247120" cy="0"/>
+          </a:xfrm>
+          <a:prstGeom prst="line">
+            <a:avLst/>
+          </a:prstGeom>
+          <a:ln w="19080">
+            <a:solidFill>
+              <a:srgbClr val="2E5C8A"/>
+            </a:solidFill>
+          </a:ln>
+        </p:spPr>
+        <p:style>
+          <a:lnRef idx="2">
+            <a:schemeClr val="accent1"/>
+          </a:lnRef>
+          <a:fillRef idx="0">
+            <a:schemeClr val="accent1"/>
+          </a:fillRef>
+          <a:effectRef idx="1">
+            <a:schemeClr val="accent1"/>
+          </a:effectRef>
+          <a:fontRef idx="minor">
+            <a:schemeClr val="tx1"/>
+          </a:fontRef>
+        </p:style>
+      </p:cxnSp>
+      <p:sp>
+        <p:nvSpPr>
+          <p:cNvPr id="4" name="TextBox 3"/>
+          <p:cNvSpPr txBox="1"/>
+          <p:nvPr/>
+        </p:nvSpPr>
+        <p:spPr>
+          <a:xfrm>
+            <a:off x="457200" y="1120000"/>
+            <a:ext cx="11246760" cy="1750000"/>
+          </a:xfrm>
+          <a:prstGeom prst="rect">
+            <a:avLst/>
+          </a:prstGeom>
+          <a:noFill/>
+        </p:spPr>
+        <p:txBody>
+          <a:bodyPr wrap="square">
+            <a:spAutoFit/>
+          </a:bodyPr>
+          <a:lstStyle/>
+          <a:p>
+            <a:pPr>
+              <a:spcAft>
+                <a:spcPts val="900"/>
+              </a:spcAft>
+            </a:pPr>
+            <a:r>
+              <a:rPr sz="1250">
+                <a:solidFill>
+                  <a:srgbClr val="333333"/>
+                </a:solidFill>
+                <a:latin typeface="Calibri"/>
+              </a:rPr>
+              <a:t>• </a:t>
+            </a:r>
+            <a:r>
+              <a:rPr sz="1250">
+                <a:solidFill>
+                  <a:srgbClr val="333333"/>
+                </a:solidFill>
+                <a:latin typeface="Calibri"/>
+              </a:rPr>
+              <a:t>Measured via the g_ctrl_step_seq counter (cseq=) -- real per-firing intervals from consecutive firmware tick= deltas, NOT the earlier dac_y-value-change proxy (which silently undercounts near settled periods and produced unusable jitter numbers, see prior entry).</a:t>
+            </a:r>
+          </a:p>
+          <a:p>
+            <a:pPr>
+              <a:spcAft>
+                <a:spcPts val="900"/>
+              </a:spcAft>
+            </a:pPr>
+            <a:r>
+              <a:rPr sz="1250">
+                <a:solidFill>
+                  <a:srgbClr val="333333"/>
+                </a:solidFill>
+                <a:latin typeface="Calibri"/>
+              </a:rPr>
+              <a:t>• </a:t>
+            </a:r>
+            <a:r>
+              <a:rPr sz="1250">
+                <a:solidFill>
+                  <a:srgbClr val="333333"/>
+                </a:solidFill>
+                <a:latin typeface="Calibri"/>
+              </a:rPr>
+              <a:t>Kp=1.75/Ki=15, axis2 on, unthrottled, 3 trials pooled: dominant cluster n=6250, mean=2.17ms, std=0.86ms, CV=39.6% — a real, honest consistency number, not the 88-127% chaos the old method gave.</a:t>
+            </a:r>
+          </a:p>
+          <a:p>
+            <a:pPr>
+              <a:spcAft>
+                <a:spcPts val="900"/>
+              </a:spcAft>
+            </a:pPr>
+            <a:r>
+              <a:rPr sz="1250">
+                <a:solidFill>
+                  <a:srgbClr val="333333"/>
+                </a:solidFill>
+                <a:latin typeface="Calibri"/>
+              </a:rPr>
+              <a:t>• </a:t>
+            </a:r>
+            <a:r>
+              <a:rPr sz="1250">
+                <a:solidFill>
+                  <a:srgbClr val="333333"/>
+                </a:solidFill>
+                <a:latin typeface="Calibri"/>
+              </a:rPr>
+              <a:t>One 174ms outlier (1 of 6251, 0.016%) excluded from the CV above and shown separately — cseq only increments on a confident detection, so this most likely reflects a brief real detection dropout, not a comms/firmware stall.</a:t>
             </a:r>
           </a:p>
         </p:txBody>
       </p:sp>
       <p:pic>
         <p:nvPicPr>
-          <p:cNvPr id="5" name="Picture 4" descr="fta_ringdown_xaxis_20260828T003210Z.png"/>
+          <p:cNvPr id="5" name="Picture 4" descr="fta_baseline_jitter_histogram.png"/>
           <p:cNvPicPr>
             <a:picLocks noChangeAspect="1"/>
           </p:cNvPicPr>
@@ -6349,231 +7494,14 @@
         </p:blipFill>
         <p:spPr>
           <a:xfrm>
-            <a:off x="457200" y="1650000"/>
-            <a:ext cx="3595587" cy="1618000"/>
+            <a:off x="3081000" y="3050000"/>
+            <a:ext cx="6030000" cy="3350000"/>
           </a:xfrm>
           <a:prstGeom prst="rect">
             <a:avLst/>
           </a:prstGeom>
         </p:spPr>
       </p:pic>
-      <p:pic>
-        <p:nvPicPr>
-          <p:cNvPr id="6" name="Picture 5" descr="fta_ringdown_xaxis_20260828T003754Z.png"/>
-          <p:cNvPicPr>
-            <a:picLocks noChangeAspect="1"/>
-          </p:cNvPicPr>
-          <p:nvPr/>
-        </p:nvPicPr>
-        <p:blipFill>
-          <a:blip r:embed="rId3"/>
-          <a:stretch>
-            <a:fillRect/>
-          </a:stretch>
-        </p:blipFill>
-        <p:spPr>
-          <a:xfrm>
-            <a:off x="4282787" y="1650000"/>
-            <a:ext cx="3595587" cy="1618000"/>
-          </a:xfrm>
-          <a:prstGeom prst="rect">
-            <a:avLst/>
-          </a:prstGeom>
-        </p:spPr>
-      </p:pic>
-      <p:pic>
-        <p:nvPicPr>
-          <p:cNvPr id="7" name="Picture 6" descr="fta_ringdown_yaxis_20260828T003403Z_fixed.png"/>
-          <p:cNvPicPr>
-            <a:picLocks noChangeAspect="1"/>
-          </p:cNvPicPr>
-          <p:nvPr/>
-        </p:nvPicPr>
-        <p:blipFill>
-          <a:blip r:embed="rId4"/>
-          <a:stretch>
-            <a:fillRect/>
-          </a:stretch>
-        </p:blipFill>
-        <p:spPr>
-          <a:xfrm>
-            <a:off x="8108374" y="1650000"/>
-            <a:ext cx="3595587" cy="1618000"/>
-          </a:xfrm>
-          <a:prstGeom prst="rect">
-            <a:avLst/>
-          </a:prstGeom>
-        </p:spPr>
-      </p:pic>
-      <p:sp>
-        <p:nvSpPr>
-          <p:cNvPr id="8" name="Caption 1"/>
-          <p:cNvSpPr txBox="1"/>
-          <p:nvPr/>
-        </p:nvSpPr>
-        <p:spPr>
-          <a:xfrm>
-            <a:off x="457200" y="3330000"/>
-            <a:ext cx="3595587" cy="700000"/>
-          </a:xfrm>
-          <a:prstGeom prst="rect">
-            <a:avLst/>
-          </a:prstGeom>
-          <a:noFill/>
-        </p:spPr>
-        <p:txBody>
-          <a:bodyPr wrap="square">
-            <a:spAutoFit/>
-          </a:bodyPr>
-          <a:lstStyle/>
-          <a:p>
-            <a:r>
-              <a:rPr sz="1150" b="1">
-                <a:solidFill>
-                  <a:srgbClr val="333333"/>
-                </a:solidFill>
-                <a:latin typeface="Calibri"/>
-              </a:rPr>
-              <a:t>X-axis, trial 1: 47.3Hz</a:t>
-            </a:r>
-          </a:p>
-          <a:p>
-            <a:r>
-              <a:rPr sz="1050">
-                <a:solidFill>
-                  <a:srgbClr val="666666"/>
-                </a:solidFill>
-                <a:latin typeface="Calibri"/>
-              </a:rPr>
-              <a:t>dac_y→cx, primary axis</a:t>
-            </a:r>
-          </a:p>
-        </p:txBody>
-      </p:sp>
-      <p:sp>
-        <p:nvSpPr>
-          <p:cNvPr id="9" name="Caption 2"/>
-          <p:cNvSpPr txBox="1"/>
-          <p:nvPr/>
-        </p:nvSpPr>
-        <p:spPr>
-          <a:xfrm>
-            <a:off x="4282787" y="3330000"/>
-            <a:ext cx="3595587" cy="700000"/>
-          </a:xfrm>
-          <a:prstGeom prst="rect">
-            <a:avLst/>
-          </a:prstGeom>
-          <a:noFill/>
-        </p:spPr>
-        <p:txBody>
-          <a:bodyPr wrap="square">
-            <a:spAutoFit/>
-          </a:bodyPr>
-          <a:lstStyle/>
-          <a:p>
-            <a:r>
-              <a:rPr sz="1150" b="1">
-                <a:solidFill>
-                  <a:srgbClr val="333333"/>
-                </a:solidFill>
-                <a:latin typeface="Calibri"/>
-              </a:rPr>
-              <a:t>X-axis, trial 2 (immediate repeat): 47.0Hz</a:t>
-            </a:r>
-          </a:p>
-          <a:p>
-            <a:r>
-              <a:rPr sz="1050">
-                <a:solidFill>
-                  <a:srgbClr val="666666"/>
-                </a:solidFill>
-                <a:latin typeface="Calibri"/>
-              </a:rPr>
-              <a:t>dac_y→cx — tight agreement with trial 1</a:t>
-            </a:r>
-          </a:p>
-        </p:txBody>
-      </p:sp>
-      <p:sp>
-        <p:nvSpPr>
-          <p:cNvPr id="10" name="Caption 3"/>
-          <p:cNvSpPr txBox="1"/>
-          <p:nvPr/>
-        </p:nvSpPr>
-        <p:spPr>
-          <a:xfrm>
-            <a:off x="8108374" y="3330000"/>
-            <a:ext cx="3595587" cy="700000"/>
-          </a:xfrm>
-          <a:prstGeom prst="rect">
-            <a:avLst/>
-          </a:prstGeom>
-          <a:noFill/>
-        </p:spPr>
-        <p:txBody>
-          <a:bodyPr wrap="square">
-            <a:spAutoFit/>
-          </a:bodyPr>
-          <a:lstStyle/>
-          <a:p>
-            <a:r>
-              <a:rPr sz="1150" b="1">
-                <a:solidFill>
-                  <a:srgbClr val="333333"/>
-                </a:solidFill>
-                <a:latin typeface="Calibri"/>
-              </a:rPr>
-              <a:t>Y-axis, first-ever trial: 50.1Hz</a:t>
-            </a:r>
-          </a:p>
-          <a:p>
-            <a:r>
-              <a:rPr sz="1050">
-                <a:solidFill>
-                  <a:srgbClr val="666666"/>
-                </a:solidFill>
-                <a:latin typeface="Calibri"/>
-              </a:rPr>
-              <a:t>dac_x→cy — only one trial so far</a:t>
-            </a:r>
-          </a:p>
-        </p:txBody>
-      </p:sp>
-      <p:sp>
-        <p:nvSpPr>
-          <p:cNvPr id="11" name="Note"/>
-          <p:cNvSpPr txBox="1"/>
-          <p:nvPr/>
-        </p:nvSpPr>
-        <p:spPr>
-          <a:xfrm>
-            <a:off x="457200" y="4200000"/>
-            <a:ext cx="11246760" cy="700000"/>
-          </a:xfrm>
-          <a:prstGeom prst="rect">
-            <a:avLst/>
-          </a:prstGeom>
-          <a:noFill/>
-        </p:spPr>
-        <p:txBody>
-          <a:bodyPr wrap="square">
-            <a:spAutoFit/>
-          </a:bodyPr>
-          <a:lstStyle/>
-          <a:p>
-            <a:r>
-              <a:rPr sz="1150" i="1">
-                <a:solidFill>
-                  <a:srgbClr val="555555"/>
-                </a:solidFill>
-                <a:latin typeface="Calibri"/>
-              </a:rPr>
-              <a:t>Both axes land close to each other and notably not close to the previously-documented 38.5Hz. Same trustworthy tick-timestamped peak-spacing method as the original measurement, so this reads as a real, reproducible shift in the physical resonance since then — see next slide for the updated FEA comparison.</a:t>
-            </a:r>
-          </a:p>
-        </p:txBody>
-      </p:sp>
     </p:spTree>
   </p:cSld>
   <p:clrMapOvr>

</xml_diff>

<commit_message>
Add axis-2 open-loop Bode plot slide to PID-tuning deck
Co-Authored-By: Claude Sonnet 5 <noreply@anthropic.com>
</commit_message>
<xml_diff>
--- a/docs/session_results_2026-08-18_pid_tuning.pptx
+++ b/docs/session_results_2026-08-18_pid_tuning.pptx
@@ -32,6 +32,7 @@
     <p:sldId id="280" r:id="rId27"/>
     <p:sldId id="281" r:id="rId28"/>
     <p:sldId id="282" r:id="rId29"/>
+    <p:sldId id="283" r:id="rId30"/>
   </p:sldIdLst>
   <p:sldSz cx="12192000" cy="6858000"/>
   <p:notesSz cx="7772400" cy="10058400"/>
@@ -8633,6 +8634,240 @@
 </p:sld>
 </file>
 
+<file path=ppt/slides/slide28.xml><?xml version="1.0" encoding="utf-8"?>
+<p:sld xmlns:a="http://schemas.openxmlformats.org/drawingml/2006/main" xmlns:p="http://schemas.openxmlformats.org/presentationml/2006/main" xmlns:r="http://schemas.openxmlformats.org/officeDocument/2006/relationships">
+  <p:cSld>
+    <p:spTree>
+      <p:nvGrpSpPr>
+        <p:cNvPr id="1" name=""/>
+        <p:cNvGrpSpPr/>
+        <p:nvPr/>
+      </p:nvGrpSpPr>
+      <p:grpSpPr/>
+      <p:sp>
+        <p:nvSpPr>
+          <p:cNvPr id="2" name="TextBox 1"/>
+          <p:cNvSpPr txBox="1"/>
+          <p:nvPr/>
+        </p:nvSpPr>
+        <p:spPr>
+          <a:xfrm>
+            <a:off x="457200" y="228600"/>
+            <a:ext cx="11246760" cy="640000"/>
+          </a:xfrm>
+          <a:prstGeom prst="rect">
+            <a:avLst/>
+          </a:prstGeom>
+          <a:noFill/>
+        </p:spPr>
+        <p:txBody>
+          <a:bodyPr wrap="square">
+            <a:spAutoFit/>
+          </a:bodyPr>
+          <a:lstStyle/>
+          <a:p>
+            <a:r>
+              <a:rPr sz="2200" b="1">
+                <a:solidFill>
+                  <a:srgbClr val="1A1A2E"/>
+                </a:solidFill>
+                <a:latin typeface="Calibri"/>
+              </a:rPr>
+              <a:t>Second axis (dac_x -&gt; cy): its own resonance, corroborated two ways</a:t>
+            </a:r>
+          </a:p>
+        </p:txBody>
+      </p:sp>
+      <p:cxnSp>
+        <p:nvCxnSpPr>
+          <p:cNvPr id="3" name="Connector 2"/>
+          <p:cNvCxnSpPr/>
+          <p:nvPr/>
+        </p:nvCxnSpPr>
+        <p:spPr>
+          <a:xfrm>
+            <a:off x="457200" y="960120"/>
+            <a:ext cx="11247120" cy="0"/>
+          </a:xfrm>
+          <a:prstGeom prst="line">
+            <a:avLst/>
+          </a:prstGeom>
+          <a:ln w="19080">
+            <a:solidFill>
+              <a:srgbClr val="2E5C8A"/>
+            </a:solidFill>
+          </a:ln>
+        </p:spPr>
+        <p:style>
+          <a:lnRef idx="2">
+            <a:schemeClr val="accent1"/>
+          </a:lnRef>
+          <a:fillRef idx="0">
+            <a:schemeClr val="accent1"/>
+          </a:fillRef>
+          <a:effectRef idx="1">
+            <a:schemeClr val="accent1"/>
+          </a:effectRef>
+          <a:fontRef idx="minor">
+            <a:schemeClr val="tx1"/>
+          </a:fontRef>
+        </p:style>
+      </p:cxnSp>
+      <p:sp>
+        <p:nvSpPr>
+          <p:cNvPr id="4" name="TextBox 3"/>
+          <p:cNvSpPr txBox="1"/>
+          <p:nvPr/>
+        </p:nvSpPr>
+        <p:spPr>
+          <a:xfrm>
+            <a:off x="457200" y="1120000"/>
+            <a:ext cx="11246760" cy="1900000"/>
+          </a:xfrm>
+          <a:prstGeom prst="rect">
+            <a:avLst/>
+          </a:prstGeom>
+          <a:noFill/>
+        </p:spPr>
+        <p:txBody>
+          <a:bodyPr wrap="square">
+            <a:spAutoFit/>
+          </a:bodyPr>
+          <a:lstStyle/>
+          <a:p>
+            <a:pPr>
+              <a:spcAft>
+                <a:spcPts val="800"/>
+              </a:spcAft>
+            </a:pPr>
+            <a:r>
+              <a:rPr sz="1300">
+                <a:solidFill>
+                  <a:srgbClr val="333333"/>
+                </a:solidFill>
+                <a:latin typeface="Calibri"/>
+              </a:rPr>
+              <a:t>• </a:t>
+            </a:r>
+            <a:r>
+              <a:rPr sz="1300">
+                <a:solidFill>
+                  <a:srgbClr val="333333"/>
+                </a:solidFill>
+                <a:latin typeface="Calibri"/>
+              </a:rPr>
+              <a:t>First-ever open-loop Bode sweep on this pathway (18 points, 1-55Hz) -- previously only a single ring-down trial and a step-response smoke test existed for this axis.</a:t>
+            </a:r>
+          </a:p>
+          <a:p>
+            <a:pPr>
+              <a:spcAft>
+                <a:spcPts val="800"/>
+              </a:spcAft>
+            </a:pPr>
+            <a:r>
+              <a:rPr sz="1300">
+                <a:solidFill>
+                  <a:srgbClr val="333333"/>
+                </a:solidFill>
+                <a:latin typeface="Calibri"/>
+              </a:rPr>
+              <a:t>• </a:t>
+            </a:r>
+            <a:r>
+              <a:rPr sz="1300">
+                <a:solidFill>
+                  <a:srgbClr val="333333"/>
+                </a:solidFill>
+                <a:latin typeface="Calibri"/>
+              </a:rPr>
+              <a:t>Real resonance found at ~47-50Hz (grid-limited), gain peaking at 0.63-0.64 px/count vs. a ~0.07-0.08 px/count low-frequency baseline (~8x amplification).</a:t>
+            </a:r>
+          </a:p>
+          <a:p>
+            <a:pPr>
+              <a:spcAft>
+                <a:spcPts val="800"/>
+              </a:spcAft>
+            </a:pPr>
+            <a:r>
+              <a:rPr sz="1300">
+                <a:solidFill>
+                  <a:srgbClr val="333333"/>
+                </a:solidFill>
+                <a:latin typeface="Calibri"/>
+              </a:rPr>
+              <a:t>• </a:t>
+            </a:r>
+            <a:r>
+              <a:rPr sz="1300">
+                <a:solidFill>
+                  <a:srgbClr val="333333"/>
+                </a:solidFill>
+                <a:latin typeface="Calibri"/>
+              </a:rPr>
+              <a:t>Closely matches the existing ring-down measurement for this SAME axis (50.1Hz) -- two independent methods (forced sine vs. free decay), same answer.</a:t>
+            </a:r>
+          </a:p>
+          <a:p>
+            <a:pPr>
+              <a:spcAft>
+                <a:spcPts val="800"/>
+              </a:spcAft>
+            </a:pPr>
+            <a:r>
+              <a:rPr sz="1300">
+                <a:solidFill>
+                  <a:srgbClr val="333333"/>
+                </a:solidFill>
+                <a:latin typeface="Calibri"/>
+              </a:rPr>
+              <a:t>• </a:t>
+            </a:r>
+            <a:r>
+              <a:rPr sz="1300">
+                <a:solidFill>
+                  <a:srgbClr val="333333"/>
+                </a:solidFill>
+                <a:latin typeface="Calibri"/>
+              </a:rPr>
+              <a:t>Gentler than the primary axis's resonance (~8x here vs. ~11x for dac_y-&gt;cx), but in the same 40-50Hz neighborhood -- worth checking whether the two axes share a common physical mode before finalizing the flexure redesign.</a:t>
+            </a:r>
+          </a:p>
+        </p:txBody>
+      </p:sp>
+      <p:pic>
+        <p:nvPicPr>
+          <p:cNvPr id="5" name="Picture 4" descr="fta_open_loop_bode_xaxis_summary.png"/>
+          <p:cNvPicPr>
+            <a:picLocks noChangeAspect="1"/>
+          </p:cNvPicPr>
+          <p:nvPr/>
+        </p:nvPicPr>
+        <p:blipFill>
+          <a:blip r:embed="rId2"/>
+          <a:stretch>
+            <a:fillRect/>
+          </a:stretch>
+        </p:blipFill>
+        <p:spPr>
+          <a:xfrm>
+            <a:off x="4367667" y="3150000"/>
+            <a:ext cx="3456666" cy="3050000"/>
+          </a:xfrm>
+          <a:prstGeom prst="rect">
+            <a:avLst/>
+          </a:prstGeom>
+        </p:spPr>
+      </p:pic>
+    </p:spTree>
+  </p:cSld>
+  <p:clrMapOvr>
+    <a:masterClrMapping/>
+  </p:clrMapOvr>
+</p:sld>
+</file>
+
 <file path=ppt/slides/slide3.xml><?xml version="1.0" encoding="utf-8"?>
 <p:sld xmlns:a="http://schemas.openxmlformats.org/drawingml/2006/main" xmlns:p="http://schemas.openxmlformats.org/presentationml/2006/main" xmlns:r="http://schemas.openxmlformats.org/officeDocument/2006/relationships" xmlns:p14="http://schemas.microsoft.com/office/powerpoint/2010/main" xmlns:p15="http://schemas.microsoft.com/office/powerpoint/2012/main" xmlns:mc="http://schemas.openxmlformats.org/markup-compatibility/2006">
   <p:cSld>

</xml_diff>

<commit_message>
docs: add missing fresh axis-1 Bode re-sweep slide before the lead-compensator slide
Co-Authored-By: Claude Sonnet 5 <noreply@anthropic.com>
Claude-Session: https://claude.ai/code/session_01DEgg2kXAu8MNgo11iiZJqM
</commit_message>
<xml_diff>
--- a/docs/session_results_2026-08-18_pid_tuning.pptx
+++ b/docs/session_results_2026-08-18_pid_tuning.pptx
@@ -30,6 +30,7 @@
     <p:sldId id="276" r:id="rId23"/>
     <p:sldId id="279" r:id="rId26"/>
     <p:sldId id="280" r:id="rId27"/>
+    <p:sldId id="284" r:id="rId31"/>
     <p:sldId id="281" r:id="rId28"/>
     <p:sldId id="282" r:id="rId29"/>
     <p:sldId id="283" r:id="rId30"/>
@@ -8868,6 +8869,240 @@
 </p:sld>
 </file>
 
+<file path=ppt/slides/slide29.xml><?xml version="1.0" encoding="utf-8"?>
+<p:sld xmlns:a="http://schemas.openxmlformats.org/drawingml/2006/main" xmlns:p="http://schemas.openxmlformats.org/presentationml/2006/main" xmlns:r="http://schemas.openxmlformats.org/officeDocument/2006/relationships">
+  <p:cSld>
+    <p:spTree>
+      <p:nvGrpSpPr>
+        <p:cNvPr id="1" name=""/>
+        <p:cNvGrpSpPr/>
+        <p:nvPr/>
+      </p:nvGrpSpPr>
+      <p:grpSpPr/>
+      <p:sp>
+        <p:nvSpPr>
+          <p:cNvPr id="2" name="TextBox 1"/>
+          <p:cNvSpPr txBox="1"/>
+          <p:nvPr/>
+        </p:nvSpPr>
+        <p:spPr>
+          <a:xfrm>
+            <a:off x="457200" y="228600"/>
+            <a:ext cx="11246760" cy="640000"/>
+          </a:xfrm>
+          <a:prstGeom prst="rect">
+            <a:avLst/>
+          </a:prstGeom>
+          <a:noFill/>
+        </p:spPr>
+        <p:txBody>
+          <a:bodyPr wrap="square">
+            <a:spAutoFit/>
+          </a:bodyPr>
+          <a:lstStyle/>
+          <a:p>
+            <a:r>
+              <a:rPr sz="2200" b="1">
+                <a:solidFill>
+                  <a:srgbClr val="1A1A2E"/>
+                </a:solidFill>
+                <a:latin typeface="Calibri"/>
+              </a:rPr>
+              <a:t>Fresh Bode re-sweep, primary axis (dac_y -&gt; cx) — same resonance shape, used to design the lead compensator</a:t>
+            </a:r>
+          </a:p>
+        </p:txBody>
+      </p:sp>
+      <p:cxnSp>
+        <p:nvCxnSpPr>
+          <p:cNvPr id="3" name="Connector 2"/>
+          <p:cNvCxnSpPr/>
+          <p:nvPr/>
+        </p:nvCxnSpPr>
+        <p:spPr>
+          <a:xfrm>
+            <a:off x="457200" y="960120"/>
+            <a:ext cx="11247120" cy="0"/>
+          </a:xfrm>
+          <a:prstGeom prst="line">
+            <a:avLst/>
+          </a:prstGeom>
+          <a:ln w="19080">
+            <a:solidFill>
+              <a:srgbClr val="2E5C8A"/>
+            </a:solidFill>
+          </a:ln>
+        </p:spPr>
+        <p:style>
+          <a:lnRef idx="2">
+            <a:schemeClr val="accent1"/>
+          </a:lnRef>
+          <a:fillRef idx="0">
+            <a:schemeClr val="accent1"/>
+          </a:fillRef>
+          <a:effectRef idx="1">
+            <a:schemeClr val="accent1"/>
+          </a:effectRef>
+          <a:fontRef idx="minor">
+            <a:schemeClr val="tx1"/>
+          </a:fontRef>
+        </p:style>
+      </p:cxnSp>
+      <p:sp>
+        <p:nvSpPr>
+          <p:cNvPr id="4" name="TextBox 3"/>
+          <p:cNvSpPr txBox="1"/>
+          <p:nvPr/>
+        </p:nvSpPr>
+        <p:spPr>
+          <a:xfrm>
+            <a:off x="457200" y="1120000"/>
+            <a:ext cx="11246760" cy="1900000"/>
+          </a:xfrm>
+          <a:prstGeom prst="rect">
+            <a:avLst/>
+          </a:prstGeom>
+          <a:noFill/>
+        </p:spPr>
+        <p:txBody>
+          <a:bodyPr wrap="square">
+            <a:spAutoFit/>
+          </a:bodyPr>
+          <a:lstStyle/>
+          <a:p>
+            <a:pPr>
+              <a:spcAft>
+                <a:spcPts val="800"/>
+              </a:spcAft>
+            </a:pPr>
+            <a:r>
+              <a:rPr sz="1300">
+                <a:solidFill>
+                  <a:srgbClr val="333333"/>
+                </a:solidFill>
+                <a:latin typeface="Calibri"/>
+              </a:rPr>
+              <a:t>• </a:t>
+            </a:r>
+            <a:r>
+              <a:rPr sz="1300">
+                <a:solidFill>
+                  <a:srgbClr val="333333"/>
+                </a:solidFill>
+                <a:latin typeface="Calibri"/>
+              </a:rPr>
+              <a:t>Fresh 18-point re-sweep (1-55Hz, amplitude reduced 300→150 counts for margin) of the same pathway already characterized on 2026-08-19 — re-run to get a clean, trustworthy basis for a new lead-compensator design.</a:t>
+            </a:r>
+          </a:p>
+          <a:p>
+            <a:pPr>
+              <a:spcAft>
+                <a:spcPts val="800"/>
+              </a:spcAft>
+            </a:pPr>
+            <a:r>
+              <a:rPr sz="1300">
+                <a:solidFill>
+                  <a:srgbClr val="333333"/>
+                </a:solidFill>
+                <a:latin typeface="Calibri"/>
+              </a:rPr>
+              <a:t>• </a:t>
+            </a:r>
+            <a:r>
+              <a:rPr sz="1300">
+                <a:solidFill>
+                  <a:srgbClr val="333333"/>
+                </a:solidFill>
+                <a:latin typeface="Calibri"/>
+              </a:rPr>
+              <a:t>Confirms the same qualitative shape as the original sweep: flat gain 1-13Hz, real phase margin through 10-20Hz (40° lag at 10Hz, matching almost exactly), then a sharp resonant peak.</a:t>
+            </a:r>
+          </a:p>
+          <a:p>
+            <a:pPr>
+              <a:spcAft>
+                <a:spcPts val="800"/>
+              </a:spcAft>
+            </a:pPr>
+            <a:r>
+              <a:rPr sz="1300">
+                <a:solidFill>
+                  <a:srgbClr val="333333"/>
+                </a:solidFill>
+                <a:latin typeface="Calibri"/>
+              </a:rPr>
+              <a:t>• </a:t>
+            </a:r>
+            <a:r>
+              <a:rPr sz="1300">
+                <a:solidFill>
+                  <a:srgbClr val="333333"/>
+                </a:solidFill>
+                <a:latin typeface="Calibri"/>
+              </a:rPr>
+              <a:t>Grid-sampled peak lands at 40Hz (~11x the low-frequency baseline gain) — grid-limited (35/40/44Hz sampled around it), so read as consistent with, not a correction to, either the 38.5Hz or ~47-50Hz ring-down numbers already on record.</a:t>
+            </a:r>
+          </a:p>
+          <a:p>
+            <a:pPr>
+              <a:spcAft>
+                <a:spcPts val="800"/>
+              </a:spcAft>
+            </a:pPr>
+            <a:r>
+              <a:rPr sz="1300">
+                <a:solidFill>
+                  <a:srgbClr val="333333"/>
+                </a:solidFill>
+                <a:latin typeface="Calibri"/>
+              </a:rPr>
+              <a:t>• </a:t>
+            </a:r>
+            <a:r>
+              <a:rPr sz="1300">
+                <a:solidFill>
+                  <a:srgbClr val="333333"/>
+                </a:solidFill>
+                <a:latin typeface="Calibri"/>
+              </a:rPr>
+              <a:t>This data was used to design the fz≈15.4Hz/fp≈26Hz lead compensator on the next slide — which failed violently on hardware, tracing back to gain this resonance skirt adds in the 15-35Hz band, not a design or coefficient error.</a:t>
+            </a:r>
+          </a:p>
+        </p:txBody>
+      </p:sp>
+      <p:pic>
+        <p:nvPicPr>
+          <p:cNvPr id="5" name="Picture 4" descr="fta_open_loop_bode_20260901_summary.png"/>
+          <p:cNvPicPr>
+            <a:picLocks noChangeAspect="1"/>
+          </p:cNvPicPr>
+          <p:nvPr/>
+        </p:nvPicPr>
+        <p:blipFill>
+          <a:blip r:embed="rId2"/>
+          <a:stretch>
+            <a:fillRect/>
+          </a:stretch>
+        </p:blipFill>
+        <p:spPr>
+          <a:xfrm>
+            <a:off x="4367667" y="3150000"/>
+            <a:ext cx="3456666" cy="3050000"/>
+          </a:xfrm>
+          <a:prstGeom prst="rect">
+            <a:avLst/>
+          </a:prstGeom>
+        </p:spPr>
+      </p:pic>
+    </p:spTree>
+  </p:cSld>
+  <p:clrMapOvr>
+    <a:masterClrMapping/>
+  </p:clrMapOvr>
+</p:sld>
+</file>
+
 <file path=ppt/slides/slide3.xml><?xml version="1.0" encoding="utf-8"?>
 <p:sld xmlns:a="http://schemas.openxmlformats.org/drawingml/2006/main" xmlns:p="http://schemas.openxmlformats.org/presentationml/2006/main" xmlns:r="http://schemas.openxmlformats.org/officeDocument/2006/relationships" xmlns:p14="http://schemas.microsoft.com/office/powerpoint/2010/main" xmlns:p15="http://schemas.microsoft.com/office/powerpoint/2012/main" xmlns:mc="http://schemas.openxmlformats.org/markup-compatibility/2006">
   <p:cSld>

</xml_diff>

<commit_message>
Add cross-axis coupling plot/slide to PID-tuning deck
Co-Authored-By: Claude Sonnet 5 <noreply@anthropic.com>
</commit_message>
<xml_diff>
--- a/docs/session_results_2026-08-18_pid_tuning.pptx
+++ b/docs/session_results_2026-08-18_pid_tuning.pptx
@@ -34,6 +34,7 @@
     <p:sldId id="281" r:id="rId28"/>
     <p:sldId id="282" r:id="rId29"/>
     <p:sldId id="283" r:id="rId30"/>
+    <p:sldId id="285" r:id="rId32"/>
   </p:sldIdLst>
   <p:sldSz cx="12192000" cy="6858000"/>
   <p:notesSz cx="7772400" cy="10058400"/>
@@ -7553,6 +7554,240 @@
                 </a:solidFill>
                 <a:latin typeface="Calibri"/>
               </a:rPr>
+              <a:t>Fresh Bode re-sweep, primary axis (dac_y -&gt; cx) — same resonance shape, used to design the lead compensator</a:t>
+            </a:r>
+          </a:p>
+        </p:txBody>
+      </p:sp>
+      <p:cxnSp>
+        <p:nvCxnSpPr>
+          <p:cNvPr id="3" name="Connector 2"/>
+          <p:cNvCxnSpPr/>
+          <p:nvPr/>
+        </p:nvCxnSpPr>
+        <p:spPr>
+          <a:xfrm>
+            <a:off x="457200" y="960120"/>
+            <a:ext cx="11247120" cy="0"/>
+          </a:xfrm>
+          <a:prstGeom prst="line">
+            <a:avLst/>
+          </a:prstGeom>
+          <a:ln w="19080">
+            <a:solidFill>
+              <a:srgbClr val="2E5C8A"/>
+            </a:solidFill>
+          </a:ln>
+        </p:spPr>
+        <p:style>
+          <a:lnRef idx="2">
+            <a:schemeClr val="accent1"/>
+          </a:lnRef>
+          <a:fillRef idx="0">
+            <a:schemeClr val="accent1"/>
+          </a:fillRef>
+          <a:effectRef idx="1">
+            <a:schemeClr val="accent1"/>
+          </a:effectRef>
+          <a:fontRef idx="minor">
+            <a:schemeClr val="tx1"/>
+          </a:fontRef>
+        </p:style>
+      </p:cxnSp>
+      <p:sp>
+        <p:nvSpPr>
+          <p:cNvPr id="4" name="TextBox 3"/>
+          <p:cNvSpPr txBox="1"/>
+          <p:nvPr/>
+        </p:nvSpPr>
+        <p:spPr>
+          <a:xfrm>
+            <a:off x="457200" y="1120000"/>
+            <a:ext cx="11246760" cy="1900000"/>
+          </a:xfrm>
+          <a:prstGeom prst="rect">
+            <a:avLst/>
+          </a:prstGeom>
+          <a:noFill/>
+        </p:spPr>
+        <p:txBody>
+          <a:bodyPr wrap="square">
+            <a:spAutoFit/>
+          </a:bodyPr>
+          <a:lstStyle/>
+          <a:p>
+            <a:pPr>
+              <a:spcAft>
+                <a:spcPts val="800"/>
+              </a:spcAft>
+            </a:pPr>
+            <a:r>
+              <a:rPr sz="1300">
+                <a:solidFill>
+                  <a:srgbClr val="333333"/>
+                </a:solidFill>
+                <a:latin typeface="Calibri"/>
+              </a:rPr>
+              <a:t>• </a:t>
+            </a:r>
+            <a:r>
+              <a:rPr sz="1300">
+                <a:solidFill>
+                  <a:srgbClr val="333333"/>
+                </a:solidFill>
+                <a:latin typeface="Calibri"/>
+              </a:rPr>
+              <a:t>Fresh 18-point re-sweep (1-55Hz, amplitude reduced 300→150 counts for margin) of the same pathway already characterized on 2026-08-19 — re-run to get a clean, trustworthy basis for a new lead-compensator design.</a:t>
+            </a:r>
+          </a:p>
+          <a:p>
+            <a:pPr>
+              <a:spcAft>
+                <a:spcPts val="800"/>
+              </a:spcAft>
+            </a:pPr>
+            <a:r>
+              <a:rPr sz="1300">
+                <a:solidFill>
+                  <a:srgbClr val="333333"/>
+                </a:solidFill>
+                <a:latin typeface="Calibri"/>
+              </a:rPr>
+              <a:t>• </a:t>
+            </a:r>
+            <a:r>
+              <a:rPr sz="1300">
+                <a:solidFill>
+                  <a:srgbClr val="333333"/>
+                </a:solidFill>
+                <a:latin typeface="Calibri"/>
+              </a:rPr>
+              <a:t>Confirms the same qualitative shape as the original sweep: flat gain 1-13Hz, real phase margin through 10-20Hz (40° lag at 10Hz, matching almost exactly), then a sharp resonant peak.</a:t>
+            </a:r>
+          </a:p>
+          <a:p>
+            <a:pPr>
+              <a:spcAft>
+                <a:spcPts val="800"/>
+              </a:spcAft>
+            </a:pPr>
+            <a:r>
+              <a:rPr sz="1300">
+                <a:solidFill>
+                  <a:srgbClr val="333333"/>
+                </a:solidFill>
+                <a:latin typeface="Calibri"/>
+              </a:rPr>
+              <a:t>• </a:t>
+            </a:r>
+            <a:r>
+              <a:rPr sz="1300">
+                <a:solidFill>
+                  <a:srgbClr val="333333"/>
+                </a:solidFill>
+                <a:latin typeface="Calibri"/>
+              </a:rPr>
+              <a:t>Grid-sampled peak lands at 40Hz (~11x the low-frequency baseline gain) — grid-limited (35/40/44Hz sampled around it), so read as consistent with, not a correction to, either the 38.5Hz or ~47-50Hz ring-down numbers already on record.</a:t>
+            </a:r>
+          </a:p>
+          <a:p>
+            <a:pPr>
+              <a:spcAft>
+                <a:spcPts val="800"/>
+              </a:spcAft>
+            </a:pPr>
+            <a:r>
+              <a:rPr sz="1300">
+                <a:solidFill>
+                  <a:srgbClr val="333333"/>
+                </a:solidFill>
+                <a:latin typeface="Calibri"/>
+              </a:rPr>
+              <a:t>• </a:t>
+            </a:r>
+            <a:r>
+              <a:rPr sz="1300">
+                <a:solidFill>
+                  <a:srgbClr val="333333"/>
+                </a:solidFill>
+                <a:latin typeface="Calibri"/>
+              </a:rPr>
+              <a:t>This data was used to design the fz≈15.4Hz/fp≈26Hz lead compensator on the next slide — which failed violently on hardware, tracing back to gain this resonance skirt adds in the 15-35Hz band, not a design or coefficient error.</a:t>
+            </a:r>
+          </a:p>
+        </p:txBody>
+      </p:sp>
+      <p:pic>
+        <p:nvPicPr>
+          <p:cNvPr id="5" name="Picture 4" descr="fta_open_loop_bode_20260901_summary.png"/>
+          <p:cNvPicPr>
+            <a:picLocks noChangeAspect="1"/>
+          </p:cNvPicPr>
+          <p:nvPr/>
+        </p:nvPicPr>
+        <p:blipFill>
+          <a:blip r:embed="rId2"/>
+          <a:stretch>
+            <a:fillRect/>
+          </a:stretch>
+        </p:blipFill>
+        <p:spPr>
+          <a:xfrm>
+            <a:off x="4367667" y="3150000"/>
+            <a:ext cx="3456666" cy="3050000"/>
+          </a:xfrm>
+          <a:prstGeom prst="rect">
+            <a:avLst/>
+          </a:prstGeom>
+        </p:spPr>
+      </p:pic>
+    </p:spTree>
+  </p:cSld>
+  <p:clrMapOvr>
+    <a:masterClrMapping/>
+  </p:clrMapOvr>
+</p:sld>
+</file>
+
+<file path=ppt/slides/slide27.xml><?xml version="1.0" encoding="utf-8"?>
+<p:sld xmlns:a="http://schemas.openxmlformats.org/drawingml/2006/main" xmlns:p="http://schemas.openxmlformats.org/presentationml/2006/main" xmlns:r="http://schemas.openxmlformats.org/officeDocument/2006/relationships">
+  <p:cSld>
+    <p:spTree>
+      <p:nvGrpSpPr>
+        <p:cNvPr id="1" name=""/>
+        <p:cNvGrpSpPr/>
+        <p:nvPr/>
+      </p:nvGrpSpPr>
+      <p:grpSpPr/>
+      <p:sp>
+        <p:nvSpPr>
+          <p:cNvPr id="2" name="TextBox 1"/>
+          <p:cNvSpPr txBox="1"/>
+          <p:nvPr/>
+        </p:nvSpPr>
+        <p:spPr>
+          <a:xfrm>
+            <a:off x="457200" y="228600"/>
+            <a:ext cx="11246760" cy="640000"/>
+          </a:xfrm>
+          <a:prstGeom prst="rect">
+            <a:avLst/>
+          </a:prstGeom>
+          <a:noFill/>
+        </p:spPr>
+        <p:txBody>
+          <a:bodyPr wrap="square">
+            <a:spAutoFit/>
+          </a:bodyPr>
+          <a:lstStyle/>
+          <a:p>
+            <a:r>
+              <a:rPr sz="2200" b="1">
+                <a:solidFill>
+                  <a:srgbClr val="1A1A2E"/>
+                </a:solidFill>
+                <a:latin typeface="Calibri"/>
+              </a:rPr>
               <a:t>Lead compensator, designed from real Bode data -- still fails, but not from a bug</a:t>
             </a:r>
           </a:p>
@@ -8043,7 +8278,7 @@
 </p:sld>
 </file>
 
-<file path=ppt/slides/slide27.xml><?xml version="1.0" encoding="utf-8"?>
+<file path=ppt/slides/slide28.xml><?xml version="1.0" encoding="utf-8"?>
 <p:sld xmlns:a="http://schemas.openxmlformats.org/drawingml/2006/main" xmlns:p="http://schemas.openxmlformats.org/presentationml/2006/main" xmlns:r="http://schemas.openxmlformats.org/officeDocument/2006/relationships">
   <p:cSld>
     <p:spTree>
@@ -8635,7 +8870,7 @@
 </p:sld>
 </file>
 
-<file path=ppt/slides/slide28.xml><?xml version="1.0" encoding="utf-8"?>
+<file path=ppt/slides/slide29.xml><?xml version="1.0" encoding="utf-8"?>
 <p:sld xmlns:a="http://schemas.openxmlformats.org/drawingml/2006/main" xmlns:p="http://schemas.openxmlformats.org/presentationml/2006/main" xmlns:r="http://schemas.openxmlformats.org/officeDocument/2006/relationships">
   <p:cSld>
     <p:spTree>
@@ -8840,240 +9075,6 @@
       <p:pic>
         <p:nvPicPr>
           <p:cNvPr id="5" name="Picture 4" descr="fta_open_loop_bode_xaxis_summary.png"/>
-          <p:cNvPicPr>
-            <a:picLocks noChangeAspect="1"/>
-          </p:cNvPicPr>
-          <p:nvPr/>
-        </p:nvPicPr>
-        <p:blipFill>
-          <a:blip r:embed="rId2"/>
-          <a:stretch>
-            <a:fillRect/>
-          </a:stretch>
-        </p:blipFill>
-        <p:spPr>
-          <a:xfrm>
-            <a:off x="4367667" y="3150000"/>
-            <a:ext cx="3456666" cy="3050000"/>
-          </a:xfrm>
-          <a:prstGeom prst="rect">
-            <a:avLst/>
-          </a:prstGeom>
-        </p:spPr>
-      </p:pic>
-    </p:spTree>
-  </p:cSld>
-  <p:clrMapOvr>
-    <a:masterClrMapping/>
-  </p:clrMapOvr>
-</p:sld>
-</file>
-
-<file path=ppt/slides/slide29.xml><?xml version="1.0" encoding="utf-8"?>
-<p:sld xmlns:a="http://schemas.openxmlformats.org/drawingml/2006/main" xmlns:p="http://schemas.openxmlformats.org/presentationml/2006/main" xmlns:r="http://schemas.openxmlformats.org/officeDocument/2006/relationships">
-  <p:cSld>
-    <p:spTree>
-      <p:nvGrpSpPr>
-        <p:cNvPr id="1" name=""/>
-        <p:cNvGrpSpPr/>
-        <p:nvPr/>
-      </p:nvGrpSpPr>
-      <p:grpSpPr/>
-      <p:sp>
-        <p:nvSpPr>
-          <p:cNvPr id="2" name="TextBox 1"/>
-          <p:cNvSpPr txBox="1"/>
-          <p:nvPr/>
-        </p:nvSpPr>
-        <p:spPr>
-          <a:xfrm>
-            <a:off x="457200" y="228600"/>
-            <a:ext cx="11246760" cy="640000"/>
-          </a:xfrm>
-          <a:prstGeom prst="rect">
-            <a:avLst/>
-          </a:prstGeom>
-          <a:noFill/>
-        </p:spPr>
-        <p:txBody>
-          <a:bodyPr wrap="square">
-            <a:spAutoFit/>
-          </a:bodyPr>
-          <a:lstStyle/>
-          <a:p>
-            <a:r>
-              <a:rPr sz="2200" b="1">
-                <a:solidFill>
-                  <a:srgbClr val="1A1A2E"/>
-                </a:solidFill>
-                <a:latin typeface="Calibri"/>
-              </a:rPr>
-              <a:t>Fresh Bode re-sweep, primary axis (dac_y -&gt; cx) — same resonance shape, used to design the lead compensator</a:t>
-            </a:r>
-          </a:p>
-        </p:txBody>
-      </p:sp>
-      <p:cxnSp>
-        <p:nvCxnSpPr>
-          <p:cNvPr id="3" name="Connector 2"/>
-          <p:cNvCxnSpPr/>
-          <p:nvPr/>
-        </p:nvCxnSpPr>
-        <p:spPr>
-          <a:xfrm>
-            <a:off x="457200" y="960120"/>
-            <a:ext cx="11247120" cy="0"/>
-          </a:xfrm>
-          <a:prstGeom prst="line">
-            <a:avLst/>
-          </a:prstGeom>
-          <a:ln w="19080">
-            <a:solidFill>
-              <a:srgbClr val="2E5C8A"/>
-            </a:solidFill>
-          </a:ln>
-        </p:spPr>
-        <p:style>
-          <a:lnRef idx="2">
-            <a:schemeClr val="accent1"/>
-          </a:lnRef>
-          <a:fillRef idx="0">
-            <a:schemeClr val="accent1"/>
-          </a:fillRef>
-          <a:effectRef idx="1">
-            <a:schemeClr val="accent1"/>
-          </a:effectRef>
-          <a:fontRef idx="minor">
-            <a:schemeClr val="tx1"/>
-          </a:fontRef>
-        </p:style>
-      </p:cxnSp>
-      <p:sp>
-        <p:nvSpPr>
-          <p:cNvPr id="4" name="TextBox 3"/>
-          <p:cNvSpPr txBox="1"/>
-          <p:nvPr/>
-        </p:nvSpPr>
-        <p:spPr>
-          <a:xfrm>
-            <a:off x="457200" y="1120000"/>
-            <a:ext cx="11246760" cy="1900000"/>
-          </a:xfrm>
-          <a:prstGeom prst="rect">
-            <a:avLst/>
-          </a:prstGeom>
-          <a:noFill/>
-        </p:spPr>
-        <p:txBody>
-          <a:bodyPr wrap="square">
-            <a:spAutoFit/>
-          </a:bodyPr>
-          <a:lstStyle/>
-          <a:p>
-            <a:pPr>
-              <a:spcAft>
-                <a:spcPts val="800"/>
-              </a:spcAft>
-            </a:pPr>
-            <a:r>
-              <a:rPr sz="1300">
-                <a:solidFill>
-                  <a:srgbClr val="333333"/>
-                </a:solidFill>
-                <a:latin typeface="Calibri"/>
-              </a:rPr>
-              <a:t>• </a:t>
-            </a:r>
-            <a:r>
-              <a:rPr sz="1300">
-                <a:solidFill>
-                  <a:srgbClr val="333333"/>
-                </a:solidFill>
-                <a:latin typeface="Calibri"/>
-              </a:rPr>
-              <a:t>Fresh 18-point re-sweep (1-55Hz, amplitude reduced 300→150 counts for margin) of the same pathway already characterized on 2026-08-19 — re-run to get a clean, trustworthy basis for a new lead-compensator design.</a:t>
-            </a:r>
-          </a:p>
-          <a:p>
-            <a:pPr>
-              <a:spcAft>
-                <a:spcPts val="800"/>
-              </a:spcAft>
-            </a:pPr>
-            <a:r>
-              <a:rPr sz="1300">
-                <a:solidFill>
-                  <a:srgbClr val="333333"/>
-                </a:solidFill>
-                <a:latin typeface="Calibri"/>
-              </a:rPr>
-              <a:t>• </a:t>
-            </a:r>
-            <a:r>
-              <a:rPr sz="1300">
-                <a:solidFill>
-                  <a:srgbClr val="333333"/>
-                </a:solidFill>
-                <a:latin typeface="Calibri"/>
-              </a:rPr>
-              <a:t>Confirms the same qualitative shape as the original sweep: flat gain 1-13Hz, real phase margin through 10-20Hz (40° lag at 10Hz, matching almost exactly), then a sharp resonant peak.</a:t>
-            </a:r>
-          </a:p>
-          <a:p>
-            <a:pPr>
-              <a:spcAft>
-                <a:spcPts val="800"/>
-              </a:spcAft>
-            </a:pPr>
-            <a:r>
-              <a:rPr sz="1300">
-                <a:solidFill>
-                  <a:srgbClr val="333333"/>
-                </a:solidFill>
-                <a:latin typeface="Calibri"/>
-              </a:rPr>
-              <a:t>• </a:t>
-            </a:r>
-            <a:r>
-              <a:rPr sz="1300">
-                <a:solidFill>
-                  <a:srgbClr val="333333"/>
-                </a:solidFill>
-                <a:latin typeface="Calibri"/>
-              </a:rPr>
-              <a:t>Grid-sampled peak lands at 40Hz (~11x the low-frequency baseline gain) — grid-limited (35/40/44Hz sampled around it), so read as consistent with, not a correction to, either the 38.5Hz or ~47-50Hz ring-down numbers already on record.</a:t>
-            </a:r>
-          </a:p>
-          <a:p>
-            <a:pPr>
-              <a:spcAft>
-                <a:spcPts val="800"/>
-              </a:spcAft>
-            </a:pPr>
-            <a:r>
-              <a:rPr sz="1300">
-                <a:solidFill>
-                  <a:srgbClr val="333333"/>
-                </a:solidFill>
-                <a:latin typeface="Calibri"/>
-              </a:rPr>
-              <a:t>• </a:t>
-            </a:r>
-            <a:r>
-              <a:rPr sz="1300">
-                <a:solidFill>
-                  <a:srgbClr val="333333"/>
-                </a:solidFill>
-                <a:latin typeface="Calibri"/>
-              </a:rPr>
-              <a:t>This data was used to design the fz≈15.4Hz/fp≈26Hz lead compensator on the next slide — which failed violently on hardware, tracing back to gain this resonance skirt adds in the 15-35Hz band, not a design or coefficient error.</a:t>
-            </a:r>
-          </a:p>
-        </p:txBody>
-      </p:sp>
-      <p:pic>
-        <p:nvPicPr>
-          <p:cNvPr id="5" name="Picture 4" descr="fta_open_loop_bode_20260901_summary.png"/>
           <p:cNvPicPr>
             <a:picLocks noChangeAspect="1"/>
           </p:cNvPicPr>
@@ -9405,6 +9406,215 @@
       <p:transition spd="slow"/>
     </mc:Fallback>
   </mc:AlternateContent>
+</p:sld>
+</file>
+
+<file path=ppt/slides/slide30.xml><?xml version="1.0" encoding="utf-8"?>
+<p:sld xmlns:a="http://schemas.openxmlformats.org/drawingml/2006/main" xmlns:p="http://schemas.openxmlformats.org/presentationml/2006/main" xmlns:r="http://schemas.openxmlformats.org/officeDocument/2006/relationships">
+  <p:cSld>
+    <p:spTree>
+      <p:nvGrpSpPr>
+        <p:cNvPr id="1" name=""/>
+        <p:cNvGrpSpPr/>
+        <p:nvPr/>
+      </p:nvGrpSpPr>
+      <p:grpSpPr/>
+      <p:sp>
+        <p:nvSpPr>
+          <p:cNvPr id="2" name="TextBox 1"/>
+          <p:cNvSpPr txBox="1"/>
+          <p:nvPr/>
+        </p:nvSpPr>
+        <p:spPr>
+          <a:xfrm>
+            <a:off x="457200" y="228600"/>
+            <a:ext cx="11246760" cy="640000"/>
+          </a:xfrm>
+          <a:prstGeom prst="rect">
+            <a:avLst/>
+          </a:prstGeom>
+          <a:noFill/>
+        </p:spPr>
+        <p:txBody>
+          <a:bodyPr wrap="square">
+            <a:spAutoFit/>
+          </a:bodyPr>
+          <a:lstStyle/>
+          <a:p>
+            <a:r>
+              <a:rPr sz="2200" b="1">
+                <a:solidFill>
+                  <a:srgbClr val="1A1A2E"/>
+                </a:solidFill>
+                <a:latin typeface="Calibri"/>
+              </a:rPr>
+              <a:t>Cross-axis coupling test: FEA's independence prediction confirmed on hardware</a:t>
+            </a:r>
+          </a:p>
+        </p:txBody>
+      </p:sp>
+      <p:cxnSp>
+        <p:nvCxnSpPr>
+          <p:cNvPr id="3" name="Connector 2"/>
+          <p:cNvCxnSpPr/>
+          <p:nvPr/>
+        </p:nvCxnSpPr>
+        <p:spPr>
+          <a:xfrm>
+            <a:off x="457200" y="960120"/>
+            <a:ext cx="11247120" cy="0"/>
+          </a:xfrm>
+          <a:prstGeom prst="line">
+            <a:avLst/>
+          </a:prstGeom>
+          <a:ln w="19080">
+            <a:solidFill>
+              <a:srgbClr val="2E5C8A"/>
+            </a:solidFill>
+          </a:ln>
+        </p:spPr>
+        <p:style>
+          <a:lnRef idx="2">
+            <a:schemeClr val="accent1"/>
+          </a:lnRef>
+          <a:fillRef idx="0">
+            <a:schemeClr val="accent1"/>
+          </a:fillRef>
+          <a:effectRef idx="1">
+            <a:schemeClr val="accent1"/>
+          </a:effectRef>
+          <a:fontRef idx="minor">
+            <a:schemeClr val="tx1"/>
+          </a:fontRef>
+        </p:style>
+      </p:cxnSp>
+      <p:sp>
+        <p:nvSpPr>
+          <p:cNvPr id="4" name="TextBox 3"/>
+          <p:cNvSpPr txBox="1"/>
+          <p:nvPr/>
+        </p:nvSpPr>
+        <p:spPr>
+          <a:xfrm>
+            <a:off x="457200" y="1120000"/>
+            <a:ext cx="11246760" cy="1550000"/>
+          </a:xfrm>
+          <a:prstGeom prst="rect">
+            <a:avLst/>
+          </a:prstGeom>
+          <a:noFill/>
+        </p:spPr>
+        <p:txBody>
+          <a:bodyPr wrap="square">
+            <a:spAutoFit/>
+          </a:bodyPr>
+          <a:lstStyle/>
+          <a:p>
+            <a:pPr>
+              <a:spcAft>
+                <a:spcPts val="700"/>
+              </a:spcAft>
+            </a:pPr>
+            <a:r>
+              <a:rPr sz="1300">
+                <a:solidFill>
+                  <a:srgbClr val="333333"/>
+                </a:solidFill>
+                <a:latin typeface="Calibri"/>
+              </a:rPr>
+              <a:t>• </a:t>
+            </a:r>
+            <a:r>
+              <a:rPr sz="1300">
+                <a:solidFill>
+                  <a:srgbClr val="333333"/>
+                </a:solidFill>
+                <a:latin typeface="Calibri"/>
+              </a:rPr>
+              <a:t>FEA predicts the two flexure axes are totally independent modes -- driven each axis at its own resonance (real, large excitation: 154.6px on dac_y@40Hz, 112.5px on dac_x@48.5Hz) and watched the OTHER axis for any response.</a:t>
+            </a:r>
+          </a:p>
+          <a:p>
+            <a:pPr>
+              <a:spcAft>
+                <a:spcPts val="700"/>
+              </a:spcAft>
+            </a:pPr>
+            <a:r>
+              <a:rPr sz="1300">
+                <a:solidFill>
+                  <a:srgbClr val="333333"/>
+                </a:solidFill>
+                <a:latin typeface="Calibri"/>
+              </a:rPr>
+              <a:t>• </a:t>
+            </a:r>
+            <a:r>
+              <a:rPr sz="1300">
+                <a:solidFill>
+                  <a:srgbClr val="333333"/>
+                </a:solidFill>
+                <a:latin typeface="Calibri"/>
+              </a:rPr>
+              <a:t>Cross-axis response in both directions was indistinguishable from that axis's own quiet-sitting noise floor (cy: 3.8px vs. 2.8px baseline std; cx: 1.3px vs. 3.5px baseline std) -- no coupling signal in either direction, despite driving right at peak excitation.</a:t>
+            </a:r>
+          </a:p>
+          <a:p>
+            <a:pPr>
+              <a:spcAft>
+                <a:spcPts val="700"/>
+              </a:spcAft>
+            </a:pPr>
+            <a:r>
+              <a:rPr sz="1300">
+                <a:solidFill>
+                  <a:srgbClr val="333333"/>
+                </a:solidFill>
+                <a:latin typeface="Calibri"/>
+              </a:rPr>
+              <a:t>• </a:t>
+            </a:r>
+            <a:r>
+              <a:rPr sz="1300">
+                <a:solidFill>
+                  <a:srgbClr val="333333"/>
+                </a:solidFill>
+                <a:latin typeface="Calibri"/>
+              </a:rPr>
+              <a:t>Confirms the FEA prediction with a real measurement, not just consistency with it -- the flexure redesign can treat the two axes as separate problems.</a:t>
+            </a:r>
+          </a:p>
+        </p:txBody>
+      </p:sp>
+      <p:pic>
+        <p:nvPicPr>
+          <p:cNvPr id="5" name="Picture 4" descr="scratch_cross_axis_coupling_plot.png"/>
+          <p:cNvPicPr>
+            <a:picLocks noChangeAspect="1"/>
+          </p:cNvPicPr>
+          <p:nvPr/>
+        </p:nvPicPr>
+        <p:blipFill>
+          <a:blip r:embed="rId2"/>
+          <a:stretch>
+            <a:fillRect/>
+          </a:stretch>
+        </p:blipFill>
+        <p:spPr>
+          <a:xfrm>
+            <a:off x="3003197" y="2750000"/>
+            <a:ext cx="6185606" cy="3550000"/>
+          </a:xfrm>
+          <a:prstGeom prst="rect">
+            <a:avLst/>
+          </a:prstGeom>
+        </p:spPr>
+      </p:pic>
+    </p:spTree>
+  </p:cSld>
+  <p:clrMapOvr>
+    <a:masterClrMapping/>
+  </p:clrMapOvr>
 </p:sld>
 </file>
 

</xml_diff>

<commit_message>
Add axis-2 tuning and wire-instability slides to PID-tuning deck
Co-Authored-By: Claude Sonnet 5 <noreply@anthropic.com>
</commit_message>
<xml_diff>
--- a/docs/session_results_2026-08-18_pid_tuning.pptx
+++ b/docs/session_results_2026-08-18_pid_tuning.pptx
@@ -36,6 +36,8 @@
     <p:sldId id="283" r:id="rId30"/>
     <p:sldId id="285" r:id="rId32"/>
     <p:sldId id="286" r:id="rId33"/>
+    <p:sldId id="287" r:id="rId34"/>
+    <p:sldId id="288" r:id="rId35"/>
   </p:sldIdLst>
   <p:sldSz cx="12192000" cy="6858000"/>
   <p:notesSz cx="7772400" cy="10058400"/>
@@ -9853,6 +9855,449 @@
 </p:sld>
 </file>
 
+<file path=ppt/slides/slide32.xml><?xml version="1.0" encoding="utf-8"?>
+<p:sld xmlns:a="http://schemas.openxmlformats.org/drawingml/2006/main" xmlns:p="http://schemas.openxmlformats.org/presentationml/2006/main" xmlns:r="http://schemas.openxmlformats.org/officeDocument/2006/relationships">
+  <p:cSld>
+    <p:spTree>
+      <p:nvGrpSpPr>
+        <p:cNvPr id="1" name=""/>
+        <p:cNvGrpSpPr/>
+        <p:nvPr/>
+      </p:nvGrpSpPr>
+      <p:grpSpPr/>
+      <p:sp>
+        <p:nvSpPr>
+          <p:cNvPr id="2" name="TextBox 1"/>
+          <p:cNvSpPr txBox="1"/>
+          <p:nvPr/>
+        </p:nvSpPr>
+        <p:spPr>
+          <a:xfrm>
+            <a:off x="457200" y="228600"/>
+            <a:ext cx="11246760" cy="640000"/>
+          </a:xfrm>
+          <a:prstGeom prst="rect">
+            <a:avLst/>
+          </a:prstGeom>
+          <a:noFill/>
+        </p:spPr>
+        <p:txBody>
+          <a:bodyPr wrap="square">
+            <a:spAutoFit/>
+          </a:bodyPr>
+          <a:lstStyle/>
+          <a:p>
+            <a:r>
+              <a:rPr sz="2100" b="1">
+                <a:solidFill>
+                  <a:srgbClr val="1A1A2E"/>
+                </a:solidFill>
+                <a:latin typeface="Calibri"/>
+              </a:rPr>
+              <a:t>Axis 2 (dac_x -&gt; cy) tuned independently for the first time -- beats axis 1's best-ever result</a:t>
+            </a:r>
+          </a:p>
+        </p:txBody>
+      </p:sp>
+      <p:cxnSp>
+        <p:nvCxnSpPr>
+          <p:cNvPr id="3" name="Connector 2"/>
+          <p:cNvCxnSpPr/>
+          <p:nvPr/>
+        </p:nvCxnSpPr>
+        <p:spPr>
+          <a:xfrm>
+            <a:off x="457200" y="960120"/>
+            <a:ext cx="11247120" cy="0"/>
+          </a:xfrm>
+          <a:prstGeom prst="line">
+            <a:avLst/>
+          </a:prstGeom>
+          <a:ln w="19080">
+            <a:solidFill>
+              <a:srgbClr val="2E5C8A"/>
+            </a:solidFill>
+          </a:ln>
+        </p:spPr>
+        <p:style>
+          <a:lnRef idx="2">
+            <a:schemeClr val="accent1"/>
+          </a:lnRef>
+          <a:fillRef idx="0">
+            <a:schemeClr val="accent1"/>
+          </a:fillRef>
+          <a:effectRef idx="1">
+            <a:schemeClr val="accent1"/>
+          </a:effectRef>
+          <a:fontRef idx="minor">
+            <a:schemeClr val="tx1"/>
+          </a:fontRef>
+        </p:style>
+      </p:cxnSp>
+      <p:sp>
+        <p:nvSpPr>
+          <p:cNvPr id="4" name="TextBox 3"/>
+          <p:cNvSpPr txBox="1"/>
+          <p:nvPr/>
+        </p:nvSpPr>
+        <p:spPr>
+          <a:xfrm>
+            <a:off x="457200" y="1120000"/>
+            <a:ext cx="11246760" cy="1650000"/>
+          </a:xfrm>
+          <a:prstGeom prst="rect">
+            <a:avLst/>
+          </a:prstGeom>
+          <a:noFill/>
+        </p:spPr>
+        <p:txBody>
+          <a:bodyPr wrap="square">
+            <a:spAutoFit/>
+          </a:bodyPr>
+          <a:lstStyle/>
+          <a:p>
+            <a:pPr>
+              <a:spcAft>
+                <a:spcPts val="700"/>
+              </a:spcAft>
+            </a:pPr>
+            <a:r>
+              <a:rPr sz="1300">
+                <a:solidFill>
+                  <a:srgbClr val="333333"/>
+                </a:solidFill>
+                <a:latin typeface="Calibri"/>
+              </a:rPr>
+              <a:t>• </a:t>
+            </a:r>
+            <a:r>
+              <a:rPr sz="1300">
+                <a:solidFill>
+                  <a:srgbClr val="333333"/>
+                </a:solidFill>
+                <a:latin typeface="Calibri"/>
+              </a:rPr>
+              <a:t>Axis 2 always mirrored axis 1's gains before today -- added independent set_kp2/set_ki2/set_kd2 and set_target_y (needed to command a step at all) to tune it on its own merits.</a:t>
+            </a:r>
+          </a:p>
+          <a:p>
+            <a:pPr>
+              <a:spcAft>
+                <a:spcPts val="700"/>
+              </a:spcAft>
+            </a:pPr>
+            <a:r>
+              <a:rPr sz="1300">
+                <a:solidFill>
+                  <a:srgbClr val="333333"/>
+                </a:solidFill>
+                <a:latin typeface="Calibri"/>
+              </a:rPr>
+              <a:t>• </a:t>
+            </a:r>
+            <a:r>
+              <a:rPr sz="1300">
+                <a:solidFill>
+                  <a:srgbClr val="333333"/>
+                </a:solidFill>
+                <a:latin typeface="Calibri"/>
+              </a:rPr>
+              <a:t>Ki bisected at Kp=1.75: real ceiling sits 750-800 (ringing/diverging past that).</a:t>
+            </a:r>
+          </a:p>
+          <a:p>
+            <a:pPr>
+              <a:spcAft>
+                <a:spcPts val="700"/>
+              </a:spcAft>
+            </a:pPr>
+            <a:r>
+              <a:rPr sz="1300">
+                <a:solidFill>
+                  <a:srgbClr val="333333"/>
+                </a:solidFill>
+                <a:latin typeface="Calibri"/>
+              </a:rPr>
+              <a:t>• </a:t>
+            </a:r>
+            <a:r>
+              <a:rPr sz="1300">
+                <a:solidFill>
+                  <a:srgbClr val="333333"/>
+                </a:solidFill>
+                <a:latin typeface="Calibri"/>
+              </a:rPr>
+              <a:t>Kp=1.75/Ki=700 chosen: 8.6% overshoot, 68.5ms settling -- clean AND the fastest point tested, beating axis 1's own historical best (141-193ms) with the same methodology.</a:t>
+            </a:r>
+          </a:p>
+        </p:txBody>
+      </p:sp>
+      <p:pic>
+        <p:nvPicPr>
+          <p:cNvPr id="5" name="Picture 4" descr="scratch_axis2_ki_bisection_plot.png"/>
+          <p:cNvPicPr>
+            <a:picLocks noChangeAspect="1"/>
+          </p:cNvPicPr>
+          <p:nvPr/>
+        </p:nvPicPr>
+        <p:blipFill>
+          <a:blip r:embed="rId2"/>
+          <a:stretch>
+            <a:fillRect/>
+          </a:stretch>
+        </p:blipFill>
+        <p:spPr>
+          <a:xfrm>
+            <a:off x="2817154" y="2950000"/>
+            <a:ext cx="6557692" cy="3100000"/>
+          </a:xfrm>
+          <a:prstGeom prst="rect">
+            <a:avLst/>
+          </a:prstGeom>
+        </p:spPr>
+      </p:pic>
+    </p:spTree>
+  </p:cSld>
+  <p:clrMapOvr>
+    <a:masterClrMapping/>
+  </p:clrMapOvr>
+</p:sld>
+</file>
+
+<file path=ppt/slides/slide33.xml><?xml version="1.0" encoding="utf-8"?>
+<p:sld xmlns:a="http://schemas.openxmlformats.org/drawingml/2006/main" xmlns:p="http://schemas.openxmlformats.org/presentationml/2006/main" xmlns:r="http://schemas.openxmlformats.org/officeDocument/2006/relationships">
+  <p:cSld>
+    <p:spTree>
+      <p:nvGrpSpPr>
+        <p:cNvPr id="1" name=""/>
+        <p:cNvGrpSpPr/>
+        <p:nvPr/>
+      </p:nvGrpSpPr>
+      <p:grpSpPr/>
+      <p:sp>
+        <p:nvSpPr>
+          <p:cNvPr id="2" name="TextBox 1"/>
+          <p:cNvSpPr txBox="1"/>
+          <p:nvPr/>
+        </p:nvSpPr>
+        <p:spPr>
+          <a:xfrm>
+            <a:off x="457200" y="228600"/>
+            <a:ext cx="11246760" cy="640000"/>
+          </a:xfrm>
+          <a:prstGeom prst="rect">
+            <a:avLst/>
+          </a:prstGeom>
+          <a:noFill/>
+        </p:spPr>
+        <p:txBody>
+          <a:bodyPr wrap="square">
+            <a:spAutoFit/>
+          </a:bodyPr>
+          <a:lstStyle/>
+          <a:p>
+            <a:r>
+              <a:rPr sz="2100" b="1">
+                <a:solidFill>
+                  <a:srgbClr val="1A1A2E"/>
+                </a:solidFill>
+                <a:latin typeface="Calibri"/>
+              </a:rPr>
+              <a:t>A real, severe wire-position instability found on axis 1 -- confirmed and fixed</a:t>
+            </a:r>
+          </a:p>
+        </p:txBody>
+      </p:sp>
+      <p:cxnSp>
+        <p:nvCxnSpPr>
+          <p:cNvPr id="3" name="Connector 2"/>
+          <p:cNvCxnSpPr/>
+          <p:nvPr/>
+        </p:nvCxnSpPr>
+        <p:spPr>
+          <a:xfrm>
+            <a:off x="457200" y="960120"/>
+            <a:ext cx="11247120" cy="0"/>
+          </a:xfrm>
+          <a:prstGeom prst="line">
+            <a:avLst/>
+          </a:prstGeom>
+          <a:ln w="19080">
+            <a:solidFill>
+              <a:srgbClr val="2E5C8A"/>
+            </a:solidFill>
+          </a:ln>
+        </p:spPr>
+        <p:style>
+          <a:lnRef idx="2">
+            <a:schemeClr val="accent1"/>
+          </a:lnRef>
+          <a:fillRef idx="0">
+            <a:schemeClr val="accent1"/>
+          </a:fillRef>
+          <a:effectRef idx="1">
+            <a:schemeClr val="accent1"/>
+          </a:effectRef>
+          <a:fontRef idx="minor">
+            <a:schemeClr val="tx1"/>
+          </a:fontRef>
+        </p:style>
+      </p:cxnSp>
+      <p:sp>
+        <p:nvSpPr>
+          <p:cNvPr id="4" name="TextBox 3"/>
+          <p:cNvSpPr txBox="1"/>
+          <p:nvPr/>
+        </p:nvSpPr>
+        <p:spPr>
+          <a:xfrm>
+            <a:off x="457200" y="1120000"/>
+            <a:ext cx="11246760" cy="1650000"/>
+          </a:xfrm>
+          <a:prstGeom prst="rect">
+            <a:avLst/>
+          </a:prstGeom>
+          <a:noFill/>
+        </p:spPr>
+        <p:txBody>
+          <a:bodyPr wrap="square">
+            <a:spAutoFit/>
+          </a:bodyPr>
+          <a:lstStyle/>
+          <a:p>
+            <a:pPr>
+              <a:spcAft>
+                <a:spcPts val="700"/>
+              </a:spcAft>
+            </a:pPr>
+            <a:r>
+              <a:rPr sz="1250">
+                <a:solidFill>
+                  <a:srgbClr val="333333"/>
+                </a:solidFill>
+                <a:latin typeface="Calibri"/>
+              </a:rPr>
+              <a:t>• </a:t>
+            </a:r>
+            <a:r>
+              <a:rPr sz="1250">
+                <a:solidFill>
+                  <a:srgbClr val="333333"/>
+                </a:solidFill>
+                <a:latin typeface="Calibri"/>
+              </a:rPr>
+              <a:t>Small-amplitude testing (motivated by the real disturbance being atmospheric, not periodic) hit a severe, non-monotonic axis-1 degradation -- much bigger than expected from step size alone.</a:t>
+            </a:r>
+          </a:p>
+          <a:p>
+            <a:pPr>
+              <a:spcAft>
+                <a:spcPts val="700"/>
+              </a:spcAft>
+            </a:pPr>
+            <a:r>
+              <a:rPr sz="1250">
+                <a:solidFill>
+                  <a:srgbClr val="333333"/>
+                </a:solidFill>
+                <a:latin typeface="Calibri"/>
+              </a:rPr>
+              <a:t>• </a:t>
+            </a:r>
+            <a:r>
+              <a:rPr sz="1250">
+                <a:solidFill>
+                  <a:srgbClr val="333333"/>
+                </a:solidFill>
+                <a:latin typeface="Calibri"/>
+              </a:rPr>
+              <a:t>Isolated to pure P (Kp=1.75, Ki=0, no integral at all): violent, SUSTAINED ~600px oscillation, present even holding a fixed point before any step. This project has never seen Kp=1.75 alone be unstable -- the known P-only boundary is ~Kp=6-6.5, over 3x higher.</a:t>
+            </a:r>
+          </a:p>
+          <a:p>
+            <a:pPr>
+              <a:spcAft>
+                <a:spcPts val="700"/>
+              </a:spcAft>
+            </a:pPr>
+            <a:r>
+              <a:rPr sz="1250">
+                <a:solidFill>
+                  <a:srgbClr val="333333"/>
+                </a:solidFill>
+                <a:latin typeface="Calibri"/>
+              </a:rPr>
+              <a:t>• </a:t>
+            </a:r>
+            <a:r>
+              <a:rPr sz="1250">
+                <a:solidFill>
+                  <a:srgbClr val="333333"/>
+                </a:solidFill>
+                <a:latin typeface="Calibri"/>
+              </a:rPr>
+              <a:t>Root cause: the wire manipulation from the same day's wire-position ring-down test -- confirmed by asking the wires be restored to their original position and rerunning the IDENTICAL test.</a:t>
+            </a:r>
+          </a:p>
+          <a:p>
+            <a:pPr>
+              <a:spcAft>
+                <a:spcPts val="700"/>
+              </a:spcAft>
+            </a:pPr>
+            <a:r>
+              <a:rPr sz="1250">
+                <a:solidFill>
+                  <a:srgbClr val="333333"/>
+                </a:solidFill>
+                <a:latin typeface="Calibri"/>
+              </a:rPr>
+              <a:t>• </a:t>
+            </a:r>
+            <a:r>
+              <a:rPr sz="1250">
+                <a:solidFill>
+                  <a:srgbClr val="333333"/>
+                </a:solidFill>
+                <a:latin typeface="Calibri"/>
+              </a:rPr>
+              <a:t>A real, standalone finding: wire routing can destabilize this rig's PRIMARY axis's basic closed-loop stability, not just shift the secondary axis's resonance frequency -- worth permanently securing the wires away from the flexure.</a:t>
+            </a:r>
+          </a:p>
+        </p:txBody>
+      </p:sp>
+      <p:pic>
+        <p:nvPicPr>
+          <p:cNvPr id="5" name="Picture 4" descr="scratch_wire_instability_before_after.png"/>
+          <p:cNvPicPr>
+            <a:picLocks noChangeAspect="1"/>
+          </p:cNvPicPr>
+          <p:nvPr/>
+        </p:nvPicPr>
+        <p:blipFill>
+          <a:blip r:embed="rId2"/>
+          <a:stretch>
+            <a:fillRect/>
+          </a:stretch>
+        </p:blipFill>
+        <p:spPr>
+          <a:xfrm>
+            <a:off x="2833981" y="3050000"/>
+            <a:ext cx="6524038" cy="2950000"/>
+          </a:xfrm>
+          <a:prstGeom prst="rect">
+            <a:avLst/>
+          </a:prstGeom>
+        </p:spPr>
+      </p:pic>
+    </p:spTree>
+  </p:cSld>
+  <p:clrMapOvr>
+    <a:masterClrMapping/>
+  </p:clrMapOvr>
+</p:sld>
+</file>
+
 <file path=ppt/slides/slide4.xml><?xml version="1.0" encoding="utf-8"?>
 <p:sld xmlns:a="http://schemas.openxmlformats.org/drawingml/2006/main" xmlns:p="http://schemas.openxmlformats.org/presentationml/2006/main" xmlns:r="http://schemas.openxmlformats.org/officeDocument/2006/relationships" xmlns:p14="http://schemas.microsoft.com/office/powerpoint/2010/main" xmlns:p15="http://schemas.microsoft.com/office/powerpoint/2012/main" xmlns:mc="http://schemas.openxmlformats.org/markup-compatibility/2006">
   <p:cSld>

</xml_diff>